<commit_message>
Presentation update + README.md update
</commit_message>
<xml_diff>
--- a/presentation/ScreenSmart_CtrlAltElite.pptx
+++ b/presentation/ScreenSmart_CtrlAltElite.pptx
@@ -1004,7 +1004,7 @@
   <p:cSld>
     <p:spTree>
       <p:nvGrpSpPr>
-        <p:cNvPr id="273" name="Shape 273"/>
+        <p:cNvPr id="275" name="Shape 275"/>
         <p:cNvGrpSpPr/>
         <p:nvPr/>
       </p:nvGrpSpPr>
@@ -1018,7 +1018,7 @@
       </p:grpSpPr>
       <p:sp>
         <p:nvSpPr>
-          <p:cNvPr id="274" name="Google Shape;274;p4:notes"/>
+          <p:cNvPr id="276" name="Google Shape;276;p4:notes"/>
           <p:cNvSpPr txBox="1"/>
           <p:nvPr>
             <p:ph idx="1" type="body"/>
@@ -1057,7 +1057,7 @@
       </p:sp>
       <p:sp>
         <p:nvSpPr>
-          <p:cNvPr id="275" name="Google Shape;275;p4:notes"/>
+          <p:cNvPr id="277" name="Google Shape;277;p4:notes"/>
           <p:cNvSpPr/>
           <p:nvPr>
             <p:ph idx="2" type="sldImg"/>
@@ -1103,7 +1103,7 @@
   <p:cSld>
     <p:spTree>
       <p:nvGrpSpPr>
-        <p:cNvPr id="349" name="Shape 349"/>
+        <p:cNvPr id="351" name="Shape 351"/>
         <p:cNvGrpSpPr/>
         <p:nvPr/>
       </p:nvGrpSpPr>
@@ -1117,7 +1117,7 @@
       </p:grpSpPr>
       <p:sp>
         <p:nvSpPr>
-          <p:cNvPr id="350" name="Google Shape;350;p5:notes"/>
+          <p:cNvPr id="352" name="Google Shape;352;p5:notes"/>
           <p:cNvSpPr txBox="1"/>
           <p:nvPr>
             <p:ph idx="1" type="body"/>
@@ -1156,7 +1156,7 @@
       </p:sp>
       <p:sp>
         <p:nvSpPr>
-          <p:cNvPr id="351" name="Google Shape;351;p5:notes"/>
+          <p:cNvPr id="353" name="Google Shape;353;p5:notes"/>
           <p:cNvSpPr/>
           <p:nvPr>
             <p:ph idx="2" type="sldImg"/>
@@ -1202,7 +1202,7 @@
   <p:cSld>
     <p:spTree>
       <p:nvGrpSpPr>
-        <p:cNvPr id="431" name="Shape 431"/>
+        <p:cNvPr id="433" name="Shape 433"/>
         <p:cNvGrpSpPr/>
         <p:nvPr/>
       </p:nvGrpSpPr>
@@ -1216,7 +1216,7 @@
       </p:grpSpPr>
       <p:sp>
         <p:nvSpPr>
-          <p:cNvPr id="432" name="Google Shape;432;p6:notes"/>
+          <p:cNvPr id="434" name="Google Shape;434;p6:notes"/>
           <p:cNvSpPr txBox="1"/>
           <p:nvPr>
             <p:ph idx="1" type="body"/>
@@ -1255,7 +1255,7 @@
       </p:sp>
       <p:sp>
         <p:nvSpPr>
-          <p:cNvPr id="433" name="Google Shape;433;p6:notes"/>
+          <p:cNvPr id="435" name="Google Shape;435;p6:notes"/>
           <p:cNvSpPr/>
           <p:nvPr>
             <p:ph idx="2" type="sldImg"/>
@@ -1301,7 +1301,7 @@
   <p:cSld>
     <p:spTree>
       <p:nvGrpSpPr>
-        <p:cNvPr id="533" name="Shape 533"/>
+        <p:cNvPr id="546" name="Shape 546"/>
         <p:cNvGrpSpPr/>
         <p:nvPr/>
       </p:nvGrpSpPr>
@@ -1315,7 +1315,7 @@
       </p:grpSpPr>
       <p:sp>
         <p:nvSpPr>
-          <p:cNvPr id="534" name="Google Shape;534;p7:notes"/>
+          <p:cNvPr id="547" name="Google Shape;547;p7:notes"/>
           <p:cNvSpPr txBox="1"/>
           <p:nvPr>
             <p:ph idx="1" type="body"/>
@@ -1354,7 +1354,7 @@
       </p:sp>
       <p:sp>
         <p:nvSpPr>
-          <p:cNvPr id="535" name="Google Shape;535;p7:notes"/>
+          <p:cNvPr id="548" name="Google Shape;548;p7:notes"/>
           <p:cNvSpPr/>
           <p:nvPr>
             <p:ph idx="2" type="sldImg"/>
@@ -1400,7 +1400,7 @@
   <p:cSld>
     <p:spTree>
       <p:nvGrpSpPr>
-        <p:cNvPr id="585" name="Shape 585"/>
+        <p:cNvPr id="599" name="Shape 599"/>
         <p:cNvGrpSpPr/>
         <p:nvPr/>
       </p:nvGrpSpPr>
@@ -1414,7 +1414,7 @@
       </p:grpSpPr>
       <p:sp>
         <p:nvSpPr>
-          <p:cNvPr id="586" name="Google Shape;586;p8:notes"/>
+          <p:cNvPr id="600" name="Google Shape;600;p8:notes"/>
           <p:cNvSpPr txBox="1"/>
           <p:nvPr>
             <p:ph idx="1" type="body"/>
@@ -1453,7 +1453,7 @@
       </p:sp>
       <p:sp>
         <p:nvSpPr>
-          <p:cNvPr id="587" name="Google Shape;587;p8:notes"/>
+          <p:cNvPr id="601" name="Google Shape;601;p8:notes"/>
           <p:cNvSpPr/>
           <p:nvPr>
             <p:ph idx="2" type="sldImg"/>
@@ -17647,7 +17647,7 @@
         <p:spPr>
           <a:xfrm>
             <a:off x="0" y="0"/>
-            <a:ext cx="12191700" cy="6858000"/>
+            <a:ext cx="12191695" cy="6858000"/>
           </a:xfrm>
           <a:prstGeom prst="rect">
             <a:avLst/>
@@ -20059,8 +20059,8 @@
         </p:nvSpPr>
         <p:spPr>
           <a:xfrm>
-            <a:off x="2831873" y="2043478"/>
-            <a:ext cx="2011800" cy="2011800"/>
+            <a:off x="1737360" y="2148840"/>
+            <a:ext cx="2011680" cy="2011680"/>
           </a:xfrm>
           <a:prstGeom prst="ellipse">
             <a:avLst/>
@@ -20116,8 +20116,61 @@
         </p:nvSpPr>
         <p:spPr>
           <a:xfrm>
-            <a:off x="2102600" y="4345345"/>
-            <a:ext cx="3657600" cy="430800"/>
+            <a:off x="1737360" y="2148840"/>
+            <a:ext cx="2011680" cy="2011680"/>
+          </a:xfrm>
+          <a:prstGeom prst="rect">
+            <a:avLst/>
+          </a:prstGeom>
+          <a:noFill/>
+          <a:ln>
+            <a:noFill/>
+          </a:ln>
+        </p:spPr>
+        <p:txBody>
+          <a:bodyPr anchorCtr="0" anchor="ctr" bIns="45700" lIns="91425" spcFirstLastPara="1" rIns="91425" wrap="square" tIns="45700">
+            <a:spAutoFit/>
+          </a:bodyPr>
+          <a:lstStyle/>
+          <a:p>
+            <a:pPr indent="0" lvl="0" marL="0" marR="0" rtl="0" algn="ctr">
+              <a:lnSpc>
+                <a:spcPct val="100000"/>
+              </a:lnSpc>
+              <a:spcBef>
+                <a:spcPts val="0"/>
+              </a:spcBef>
+              <a:spcAft>
+                <a:spcPts val="0"/>
+              </a:spcAft>
+              <a:buNone/>
+            </a:pPr>
+            <a:r>
+              <a:rPr b="1" i="0" lang="en-US" sz="4000" u="none" cap="none" strike="noStrike">
+                <a:solidFill>
+                  <a:srgbClr val="38BDF8"/>
+                </a:solidFill>
+                <a:latin typeface="Quattrocento Sans"/>
+                <a:ea typeface="Quattrocento Sans"/>
+                <a:cs typeface="Quattrocento Sans"/>
+                <a:sym typeface="Quattrocento Sans"/>
+              </a:rPr>
+              <a:t>MS</a:t>
+            </a:r>
+            <a:endParaRPr/>
+          </a:p>
+        </p:txBody>
+      </p:sp>
+      <p:sp>
+        <p:nvSpPr>
+          <p:cNvPr id="266" name="Google Shape;266;p15"/>
+          <p:cNvSpPr txBox="1"/>
+          <p:nvPr/>
+        </p:nvSpPr>
+        <p:spPr>
+          <a:xfrm>
+            <a:off x="914400" y="4389120"/>
+            <a:ext cx="3657600" cy="457200"/>
           </a:xfrm>
           <a:prstGeom prst="rect">
             <a:avLst/>
@@ -20163,14 +20216,14 @@
       </p:sp>
       <p:sp>
         <p:nvSpPr>
-          <p:cNvPr id="266" name="Google Shape;266;p15"/>
+          <p:cNvPr id="267" name="Google Shape;267;p15"/>
           <p:cNvSpPr txBox="1"/>
           <p:nvPr/>
         </p:nvSpPr>
         <p:spPr>
           <a:xfrm>
-            <a:off x="2102600" y="4955915"/>
-            <a:ext cx="3657600" cy="307800"/>
+            <a:off x="914400" y="4892040"/>
+            <a:ext cx="3657600" cy="365760"/>
           </a:xfrm>
           <a:prstGeom prst="rect">
             <a:avLst/>
@@ -20216,14 +20269,14 @@
       </p:sp>
       <p:sp>
         <p:nvSpPr>
-          <p:cNvPr id="267" name="Google Shape;267;p15"/>
-          <p:cNvSpPr/>
-          <p:nvPr/>
-        </p:nvSpPr>
-        <p:spPr>
-          <a:xfrm>
-            <a:off x="7658985" y="2066540"/>
-            <a:ext cx="2011800" cy="2011800"/>
+          <p:cNvPr id="268" name="Google Shape;268;p15"/>
+          <p:cNvSpPr/>
+          <p:nvPr/>
+        </p:nvSpPr>
+        <p:spPr>
+          <a:xfrm>
+            <a:off x="6309360" y="2148840"/>
+            <a:ext cx="2011680" cy="2011680"/>
           </a:xfrm>
           <a:prstGeom prst="ellipse">
             <a:avLst/>
@@ -20273,14 +20326,67 @@
       </p:sp>
       <p:sp>
         <p:nvSpPr>
-          <p:cNvPr id="268" name="Google Shape;268;p15"/>
+          <p:cNvPr id="269" name="Google Shape;269;p15"/>
           <p:cNvSpPr txBox="1"/>
           <p:nvPr/>
         </p:nvSpPr>
         <p:spPr>
           <a:xfrm>
-            <a:off x="6836075" y="4318670"/>
-            <a:ext cx="3657600" cy="430800"/>
+            <a:off x="6309360" y="2148840"/>
+            <a:ext cx="2011680" cy="2011680"/>
+          </a:xfrm>
+          <a:prstGeom prst="rect">
+            <a:avLst/>
+          </a:prstGeom>
+          <a:noFill/>
+          <a:ln>
+            <a:noFill/>
+          </a:ln>
+        </p:spPr>
+        <p:txBody>
+          <a:bodyPr anchorCtr="0" anchor="ctr" bIns="45700" lIns="91425" spcFirstLastPara="1" rIns="91425" wrap="square" tIns="45700">
+            <a:spAutoFit/>
+          </a:bodyPr>
+          <a:lstStyle/>
+          <a:p>
+            <a:pPr indent="0" lvl="0" marL="0" marR="0" rtl="0" algn="ctr">
+              <a:lnSpc>
+                <a:spcPct val="100000"/>
+              </a:lnSpc>
+              <a:spcBef>
+                <a:spcPts val="0"/>
+              </a:spcBef>
+              <a:spcAft>
+                <a:spcPts val="0"/>
+              </a:spcAft>
+              <a:buNone/>
+            </a:pPr>
+            <a:r>
+              <a:rPr b="1" i="0" lang="en-US" sz="4000" u="none" cap="none" strike="noStrike">
+                <a:solidFill>
+                  <a:srgbClr val="818CF8"/>
+                </a:solidFill>
+                <a:latin typeface="Quattrocento Sans"/>
+                <a:ea typeface="Quattrocento Sans"/>
+                <a:cs typeface="Quattrocento Sans"/>
+                <a:sym typeface="Quattrocento Sans"/>
+              </a:rPr>
+              <a:t>AM</a:t>
+            </a:r>
+            <a:endParaRPr/>
+          </a:p>
+        </p:txBody>
+      </p:sp>
+      <p:sp>
+        <p:nvSpPr>
+          <p:cNvPr id="270" name="Google Shape;270;p15"/>
+          <p:cNvSpPr txBox="1"/>
+          <p:nvPr/>
+        </p:nvSpPr>
+        <p:spPr>
+          <a:xfrm>
+            <a:off x="5486400" y="4389120"/>
+            <a:ext cx="3657600" cy="457200"/>
           </a:xfrm>
           <a:prstGeom prst="rect">
             <a:avLst/>
@@ -20326,14 +20432,14 @@
       </p:sp>
       <p:sp>
         <p:nvSpPr>
-          <p:cNvPr id="269" name="Google Shape;269;p15"/>
+          <p:cNvPr id="271" name="Google Shape;271;p15"/>
           <p:cNvSpPr txBox="1"/>
           <p:nvPr/>
         </p:nvSpPr>
         <p:spPr>
           <a:xfrm>
-            <a:off x="6836075" y="4907440"/>
-            <a:ext cx="3657600" cy="307800"/>
+            <a:off x="5486400" y="4892040"/>
+            <a:ext cx="3657600" cy="365760"/>
           </a:xfrm>
           <a:prstGeom prst="rect">
             <a:avLst/>
@@ -20379,7 +20485,7 @@
       </p:sp>
       <p:sp>
         <p:nvSpPr>
-          <p:cNvPr id="270" name="Google Shape;270;p15"/>
+          <p:cNvPr id="272" name="Google Shape;272;p15"/>
           <p:cNvSpPr txBox="1"/>
           <p:nvPr/>
         </p:nvSpPr>
@@ -20432,7 +20538,7 @@
       </p:sp>
       <p:pic>
         <p:nvPicPr>
-          <p:cNvPr descr="garaza_logo.png" id="271" name="Google Shape;271;p15"/>
+          <p:cNvPr descr="garaza_logo.png" id="273" name="Google Shape;273;p15"/>
           <p:cNvPicPr preferRelativeResize="0"/>
           <p:nvPr/>
         </p:nvPicPr>
@@ -20459,7 +20565,7 @@
       </p:pic>
       <p:sp>
         <p:nvSpPr>
-          <p:cNvPr id="272" name="Google Shape;272;p15"/>
+          <p:cNvPr id="274" name="Google Shape;274;p15"/>
           <p:cNvSpPr txBox="1"/>
           <p:nvPr/>
         </p:nvSpPr>
@@ -20535,7 +20641,7 @@
   <p:cSld>
     <p:spTree>
       <p:nvGrpSpPr>
-        <p:cNvPr id="276" name="Shape 276"/>
+        <p:cNvPr id="278" name="Shape 278"/>
         <p:cNvGrpSpPr/>
         <p:nvPr/>
       </p:nvGrpSpPr>
@@ -20549,7 +20655,7 @@
       </p:grpSpPr>
       <p:sp>
         <p:nvSpPr>
-          <p:cNvPr id="277" name="Google Shape;277;p16"/>
+          <p:cNvPr id="279" name="Google Shape;279;p16"/>
           <p:cNvSpPr/>
           <p:nvPr/>
         </p:nvSpPr>
@@ -20600,7 +20706,7 @@
       </p:sp>
       <p:sp>
         <p:nvSpPr>
-          <p:cNvPr id="278" name="Google Shape;278;p16"/>
+          <p:cNvPr id="280" name="Google Shape;280;p16"/>
           <p:cNvSpPr/>
           <p:nvPr/>
         </p:nvSpPr>
@@ -20651,7 +20757,7 @@
       </p:sp>
       <p:sp>
         <p:nvSpPr>
-          <p:cNvPr id="279" name="Google Shape;279;p16"/>
+          <p:cNvPr id="281" name="Google Shape;281;p16"/>
           <p:cNvSpPr/>
           <p:nvPr/>
         </p:nvSpPr>
@@ -20702,7 +20808,7 @@
       </p:sp>
       <p:sp>
         <p:nvSpPr>
-          <p:cNvPr id="280" name="Google Shape;280;p16"/>
+          <p:cNvPr id="282" name="Google Shape;282;p16"/>
           <p:cNvSpPr/>
           <p:nvPr/>
         </p:nvSpPr>
@@ -20753,7 +20859,7 @@
       </p:sp>
       <p:sp>
         <p:nvSpPr>
-          <p:cNvPr id="281" name="Google Shape;281;p16"/>
+          <p:cNvPr id="283" name="Google Shape;283;p16"/>
           <p:cNvSpPr/>
           <p:nvPr/>
         </p:nvSpPr>
@@ -20804,7 +20910,7 @@
       </p:sp>
       <p:sp>
         <p:nvSpPr>
-          <p:cNvPr id="282" name="Google Shape;282;p16"/>
+          <p:cNvPr id="284" name="Google Shape;284;p16"/>
           <p:cNvSpPr/>
           <p:nvPr/>
         </p:nvSpPr>
@@ -20855,7 +20961,7 @@
       </p:sp>
       <p:sp>
         <p:nvSpPr>
-          <p:cNvPr id="283" name="Google Shape;283;p16"/>
+          <p:cNvPr id="285" name="Google Shape;285;p16"/>
           <p:cNvSpPr/>
           <p:nvPr/>
         </p:nvSpPr>
@@ -20906,7 +21012,7 @@
       </p:sp>
       <p:sp>
         <p:nvSpPr>
-          <p:cNvPr id="284" name="Google Shape;284;p16"/>
+          <p:cNvPr id="286" name="Google Shape;286;p16"/>
           <p:cNvSpPr/>
           <p:nvPr/>
         </p:nvSpPr>
@@ -20957,7 +21063,7 @@
       </p:sp>
       <p:sp>
         <p:nvSpPr>
-          <p:cNvPr id="285" name="Google Shape;285;p16"/>
+          <p:cNvPr id="287" name="Google Shape;287;p16"/>
           <p:cNvSpPr/>
           <p:nvPr/>
         </p:nvSpPr>
@@ -21008,7 +21114,7 @@
       </p:sp>
       <p:sp>
         <p:nvSpPr>
-          <p:cNvPr id="286" name="Google Shape;286;p16"/>
+          <p:cNvPr id="288" name="Google Shape;288;p16"/>
           <p:cNvSpPr/>
           <p:nvPr/>
         </p:nvSpPr>
@@ -21059,7 +21165,7 @@
       </p:sp>
       <p:sp>
         <p:nvSpPr>
-          <p:cNvPr id="287" name="Google Shape;287;p16"/>
+          <p:cNvPr id="289" name="Google Shape;289;p16"/>
           <p:cNvSpPr/>
           <p:nvPr/>
         </p:nvSpPr>
@@ -21110,7 +21216,7 @@
       </p:sp>
       <p:sp>
         <p:nvSpPr>
-          <p:cNvPr id="288" name="Google Shape;288;p16"/>
+          <p:cNvPr id="290" name="Google Shape;290;p16"/>
           <p:cNvSpPr/>
           <p:nvPr/>
         </p:nvSpPr>
@@ -21161,7 +21267,7 @@
       </p:sp>
       <p:sp>
         <p:nvSpPr>
-          <p:cNvPr id="289" name="Google Shape;289;p16"/>
+          <p:cNvPr id="291" name="Google Shape;291;p16"/>
           <p:cNvSpPr/>
           <p:nvPr/>
         </p:nvSpPr>
@@ -21212,7 +21318,7 @@
       </p:sp>
       <p:sp>
         <p:nvSpPr>
-          <p:cNvPr id="290" name="Google Shape;290;p16"/>
+          <p:cNvPr id="292" name="Google Shape;292;p16"/>
           <p:cNvSpPr/>
           <p:nvPr/>
         </p:nvSpPr>
@@ -21263,7 +21369,7 @@
       </p:sp>
       <p:sp>
         <p:nvSpPr>
-          <p:cNvPr id="291" name="Google Shape;291;p16"/>
+          <p:cNvPr id="293" name="Google Shape;293;p16"/>
           <p:cNvSpPr/>
           <p:nvPr/>
         </p:nvSpPr>
@@ -21314,7 +21420,7 @@
       </p:sp>
       <p:sp>
         <p:nvSpPr>
-          <p:cNvPr id="292" name="Google Shape;292;p16"/>
+          <p:cNvPr id="294" name="Google Shape;294;p16"/>
           <p:cNvSpPr/>
           <p:nvPr/>
         </p:nvSpPr>
@@ -21365,7 +21471,7 @@
       </p:sp>
       <p:sp>
         <p:nvSpPr>
-          <p:cNvPr id="293" name="Google Shape;293;p16"/>
+          <p:cNvPr id="295" name="Google Shape;295;p16"/>
           <p:cNvSpPr/>
           <p:nvPr/>
         </p:nvSpPr>
@@ -21416,7 +21522,7 @@
       </p:sp>
       <p:sp>
         <p:nvSpPr>
-          <p:cNvPr id="294" name="Google Shape;294;p16"/>
+          <p:cNvPr id="296" name="Google Shape;296;p16"/>
           <p:cNvSpPr/>
           <p:nvPr/>
         </p:nvSpPr>
@@ -21467,7 +21573,7 @@
       </p:sp>
       <p:sp>
         <p:nvSpPr>
-          <p:cNvPr id="295" name="Google Shape;295;p16"/>
+          <p:cNvPr id="297" name="Google Shape;297;p16"/>
           <p:cNvSpPr/>
           <p:nvPr/>
         </p:nvSpPr>
@@ -21518,7 +21624,7 @@
       </p:sp>
       <p:sp>
         <p:nvSpPr>
-          <p:cNvPr id="296" name="Google Shape;296;p16"/>
+          <p:cNvPr id="298" name="Google Shape;298;p16"/>
           <p:cNvSpPr/>
           <p:nvPr/>
         </p:nvSpPr>
@@ -21569,7 +21675,7 @@
       </p:sp>
       <p:sp>
         <p:nvSpPr>
-          <p:cNvPr id="297" name="Google Shape;297;p16"/>
+          <p:cNvPr id="299" name="Google Shape;299;p16"/>
           <p:cNvSpPr/>
           <p:nvPr/>
         </p:nvSpPr>
@@ -21620,7 +21726,7 @@
       </p:sp>
       <p:sp>
         <p:nvSpPr>
-          <p:cNvPr id="298" name="Google Shape;298;p16"/>
+          <p:cNvPr id="300" name="Google Shape;300;p16"/>
           <p:cNvSpPr/>
           <p:nvPr/>
         </p:nvSpPr>
@@ -21671,7 +21777,7 @@
       </p:sp>
       <p:sp>
         <p:nvSpPr>
-          <p:cNvPr id="299" name="Google Shape;299;p16"/>
+          <p:cNvPr id="301" name="Google Shape;301;p16"/>
           <p:cNvSpPr/>
           <p:nvPr/>
         </p:nvSpPr>
@@ -21722,7 +21828,7 @@
       </p:sp>
       <p:sp>
         <p:nvSpPr>
-          <p:cNvPr id="300" name="Google Shape;300;p16"/>
+          <p:cNvPr id="302" name="Google Shape;302;p16"/>
           <p:cNvSpPr/>
           <p:nvPr/>
         </p:nvSpPr>
@@ -21773,7 +21879,7 @@
       </p:sp>
       <p:sp>
         <p:nvSpPr>
-          <p:cNvPr id="301" name="Google Shape;301;p16"/>
+          <p:cNvPr id="303" name="Google Shape;303;p16"/>
           <p:cNvSpPr/>
           <p:nvPr/>
         </p:nvSpPr>
@@ -21824,7 +21930,7 @@
       </p:sp>
       <p:sp>
         <p:nvSpPr>
-          <p:cNvPr id="302" name="Google Shape;302;p16"/>
+          <p:cNvPr id="304" name="Google Shape;304;p16"/>
           <p:cNvSpPr/>
           <p:nvPr/>
         </p:nvSpPr>
@@ -21875,7 +21981,7 @@
       </p:sp>
       <p:sp>
         <p:nvSpPr>
-          <p:cNvPr id="303" name="Google Shape;303;p16"/>
+          <p:cNvPr id="305" name="Google Shape;305;p16"/>
           <p:cNvSpPr/>
           <p:nvPr/>
         </p:nvSpPr>
@@ -21926,7 +22032,7 @@
       </p:sp>
       <p:sp>
         <p:nvSpPr>
-          <p:cNvPr id="304" name="Google Shape;304;p16"/>
+          <p:cNvPr id="306" name="Google Shape;306;p16"/>
           <p:cNvSpPr/>
           <p:nvPr/>
         </p:nvSpPr>
@@ -21977,7 +22083,7 @@
       </p:sp>
       <p:sp>
         <p:nvSpPr>
-          <p:cNvPr id="305" name="Google Shape;305;p16"/>
+          <p:cNvPr id="307" name="Google Shape;307;p16"/>
           <p:cNvSpPr/>
           <p:nvPr/>
         </p:nvSpPr>
@@ -22028,7 +22134,7 @@
       </p:sp>
       <p:sp>
         <p:nvSpPr>
-          <p:cNvPr id="306" name="Google Shape;306;p16"/>
+          <p:cNvPr id="308" name="Google Shape;308;p16"/>
           <p:cNvSpPr/>
           <p:nvPr/>
         </p:nvSpPr>
@@ -22079,7 +22185,7 @@
       </p:sp>
       <p:sp>
         <p:nvSpPr>
-          <p:cNvPr id="307" name="Google Shape;307;p16"/>
+          <p:cNvPr id="309" name="Google Shape;309;p16"/>
           <p:cNvSpPr/>
           <p:nvPr/>
         </p:nvSpPr>
@@ -22130,7 +22236,7 @@
       </p:sp>
       <p:sp>
         <p:nvSpPr>
-          <p:cNvPr id="308" name="Google Shape;308;p16"/>
+          <p:cNvPr id="310" name="Google Shape;310;p16"/>
           <p:cNvSpPr/>
           <p:nvPr/>
         </p:nvSpPr>
@@ -22181,7 +22287,7 @@
       </p:sp>
       <p:sp>
         <p:nvSpPr>
-          <p:cNvPr id="309" name="Google Shape;309;p16"/>
+          <p:cNvPr id="311" name="Google Shape;311;p16"/>
           <p:cNvSpPr/>
           <p:nvPr/>
         </p:nvSpPr>
@@ -22232,7 +22338,7 @@
       </p:sp>
       <p:sp>
         <p:nvSpPr>
-          <p:cNvPr id="310" name="Google Shape;310;p16"/>
+          <p:cNvPr id="312" name="Google Shape;312;p16"/>
           <p:cNvSpPr/>
           <p:nvPr/>
         </p:nvSpPr>
@@ -22283,7 +22389,7 @@
       </p:sp>
       <p:sp>
         <p:nvSpPr>
-          <p:cNvPr id="311" name="Google Shape;311;p16"/>
+          <p:cNvPr id="313" name="Google Shape;313;p16"/>
           <p:cNvSpPr/>
           <p:nvPr/>
         </p:nvSpPr>
@@ -22334,7 +22440,7 @@
       </p:sp>
       <p:sp>
         <p:nvSpPr>
-          <p:cNvPr id="312" name="Google Shape;312;p16"/>
+          <p:cNvPr id="314" name="Google Shape;314;p16"/>
           <p:cNvSpPr/>
           <p:nvPr/>
         </p:nvSpPr>
@@ -22385,7 +22491,7 @@
       </p:sp>
       <p:sp>
         <p:nvSpPr>
-          <p:cNvPr id="313" name="Google Shape;313;p16"/>
+          <p:cNvPr id="315" name="Google Shape;315;p16"/>
           <p:cNvSpPr/>
           <p:nvPr/>
         </p:nvSpPr>
@@ -22436,7 +22542,7 @@
       </p:sp>
       <p:sp>
         <p:nvSpPr>
-          <p:cNvPr id="314" name="Google Shape;314;p16"/>
+          <p:cNvPr id="316" name="Google Shape;316;p16"/>
           <p:cNvSpPr/>
           <p:nvPr/>
         </p:nvSpPr>
@@ -22487,7 +22593,7 @@
       </p:sp>
       <p:sp>
         <p:nvSpPr>
-          <p:cNvPr id="315" name="Google Shape;315;p16"/>
+          <p:cNvPr id="317" name="Google Shape;317;p16"/>
           <p:cNvSpPr/>
           <p:nvPr/>
         </p:nvSpPr>
@@ -22538,7 +22644,7 @@
       </p:sp>
       <p:sp>
         <p:nvSpPr>
-          <p:cNvPr id="316" name="Google Shape;316;p16"/>
+          <p:cNvPr id="318" name="Google Shape;318;p16"/>
           <p:cNvSpPr/>
           <p:nvPr/>
         </p:nvSpPr>
@@ -22589,7 +22695,7 @@
       </p:sp>
       <p:sp>
         <p:nvSpPr>
-          <p:cNvPr id="317" name="Google Shape;317;p16"/>
+          <p:cNvPr id="319" name="Google Shape;319;p16"/>
           <p:cNvSpPr/>
           <p:nvPr/>
         </p:nvSpPr>
@@ -22640,7 +22746,7 @@
       </p:sp>
       <p:sp>
         <p:nvSpPr>
-          <p:cNvPr id="318" name="Google Shape;318;p16"/>
+          <p:cNvPr id="320" name="Google Shape;320;p16"/>
           <p:cNvSpPr/>
           <p:nvPr/>
         </p:nvSpPr>
@@ -22691,7 +22797,7 @@
       </p:sp>
       <p:sp>
         <p:nvSpPr>
-          <p:cNvPr id="319" name="Google Shape;319;p16"/>
+          <p:cNvPr id="321" name="Google Shape;321;p16"/>
           <p:cNvSpPr/>
           <p:nvPr/>
         </p:nvSpPr>
@@ -22742,7 +22848,7 @@
       </p:sp>
       <p:sp>
         <p:nvSpPr>
-          <p:cNvPr id="320" name="Google Shape;320;p16"/>
+          <p:cNvPr id="322" name="Google Shape;322;p16"/>
           <p:cNvSpPr/>
           <p:nvPr/>
         </p:nvSpPr>
@@ -22793,7 +22899,7 @@
       </p:sp>
       <p:sp>
         <p:nvSpPr>
-          <p:cNvPr id="321" name="Google Shape;321;p16"/>
+          <p:cNvPr id="323" name="Google Shape;323;p16"/>
           <p:cNvSpPr/>
           <p:nvPr/>
         </p:nvSpPr>
@@ -22844,7 +22950,7 @@
       </p:sp>
       <p:sp>
         <p:nvSpPr>
-          <p:cNvPr id="322" name="Google Shape;322;p16"/>
+          <p:cNvPr id="324" name="Google Shape;324;p16"/>
           <p:cNvSpPr txBox="1"/>
           <p:nvPr/>
         </p:nvSpPr>
@@ -22909,7 +23015,7 @@
       </p:sp>
       <p:sp>
         <p:nvSpPr>
-          <p:cNvPr id="323" name="Google Shape;323;p16"/>
+          <p:cNvPr id="325" name="Google Shape;325;p16"/>
           <p:cNvSpPr txBox="1"/>
           <p:nvPr/>
         </p:nvSpPr>
@@ -22962,7 +23068,7 @@
       </p:sp>
       <p:sp>
         <p:nvSpPr>
-          <p:cNvPr id="324" name="Google Shape;324;p16"/>
+          <p:cNvPr id="326" name="Google Shape;326;p16"/>
           <p:cNvSpPr txBox="1"/>
           <p:nvPr/>
         </p:nvSpPr>
@@ -23015,7 +23121,7 @@
       </p:sp>
       <p:sp>
         <p:nvSpPr>
-          <p:cNvPr id="325" name="Google Shape;325;p16"/>
+          <p:cNvPr id="327" name="Google Shape;327;p16"/>
           <p:cNvSpPr/>
           <p:nvPr/>
         </p:nvSpPr>
@@ -23074,7 +23180,7 @@
       </p:sp>
       <p:sp>
         <p:nvSpPr>
-          <p:cNvPr id="326" name="Google Shape;326;p16"/>
+          <p:cNvPr id="328" name="Google Shape;328;p16"/>
           <p:cNvSpPr/>
           <p:nvPr/>
         </p:nvSpPr>
@@ -23131,7 +23237,7 @@
       </p:sp>
       <p:sp>
         <p:nvSpPr>
-          <p:cNvPr id="327" name="Google Shape;327;p16"/>
+          <p:cNvPr id="329" name="Google Shape;329;p16"/>
           <p:cNvSpPr txBox="1"/>
           <p:nvPr/>
         </p:nvSpPr>
@@ -23184,7 +23290,7 @@
       </p:sp>
       <p:sp>
         <p:nvSpPr>
-          <p:cNvPr id="328" name="Google Shape;328;p16"/>
+          <p:cNvPr id="330" name="Google Shape;330;p16"/>
           <p:cNvSpPr txBox="1"/>
           <p:nvPr/>
         </p:nvSpPr>
@@ -23237,7 +23343,7 @@
       </p:sp>
       <p:sp>
         <p:nvSpPr>
-          <p:cNvPr id="329" name="Google Shape;329;p16"/>
+          <p:cNvPr id="331" name="Google Shape;331;p16"/>
           <p:cNvSpPr txBox="1"/>
           <p:nvPr/>
         </p:nvSpPr>
@@ -23290,7 +23396,7 @@
       </p:sp>
       <p:sp>
         <p:nvSpPr>
-          <p:cNvPr id="330" name="Google Shape;330;p16"/>
+          <p:cNvPr id="332" name="Google Shape;332;p16"/>
           <p:cNvSpPr/>
           <p:nvPr/>
         </p:nvSpPr>
@@ -23349,7 +23455,7 @@
       </p:sp>
       <p:sp>
         <p:nvSpPr>
-          <p:cNvPr id="331" name="Google Shape;331;p16"/>
+          <p:cNvPr id="333" name="Google Shape;333;p16"/>
           <p:cNvSpPr/>
           <p:nvPr/>
         </p:nvSpPr>
@@ -23406,7 +23512,7 @@
       </p:sp>
       <p:sp>
         <p:nvSpPr>
-          <p:cNvPr id="332" name="Google Shape;332;p16"/>
+          <p:cNvPr id="334" name="Google Shape;334;p16"/>
           <p:cNvSpPr txBox="1"/>
           <p:nvPr/>
         </p:nvSpPr>
@@ -23459,7 +23565,7 @@
       </p:sp>
       <p:sp>
         <p:nvSpPr>
-          <p:cNvPr id="333" name="Google Shape;333;p16"/>
+          <p:cNvPr id="335" name="Google Shape;335;p16"/>
           <p:cNvSpPr txBox="1"/>
           <p:nvPr/>
         </p:nvSpPr>
@@ -23512,7 +23618,7 @@
       </p:sp>
       <p:sp>
         <p:nvSpPr>
-          <p:cNvPr id="334" name="Google Shape;334;p16"/>
+          <p:cNvPr id="336" name="Google Shape;336;p16"/>
           <p:cNvSpPr txBox="1"/>
           <p:nvPr/>
         </p:nvSpPr>
@@ -23565,7 +23671,7 @@
       </p:sp>
       <p:sp>
         <p:nvSpPr>
-          <p:cNvPr id="335" name="Google Shape;335;p16"/>
+          <p:cNvPr id="337" name="Google Shape;337;p16"/>
           <p:cNvSpPr/>
           <p:nvPr/>
         </p:nvSpPr>
@@ -23624,7 +23730,7 @@
       </p:sp>
       <p:sp>
         <p:nvSpPr>
-          <p:cNvPr id="336" name="Google Shape;336;p16"/>
+          <p:cNvPr id="338" name="Google Shape;338;p16"/>
           <p:cNvSpPr/>
           <p:nvPr/>
         </p:nvSpPr>
@@ -23681,7 +23787,7 @@
       </p:sp>
       <p:sp>
         <p:nvSpPr>
-          <p:cNvPr id="337" name="Google Shape;337;p16"/>
+          <p:cNvPr id="339" name="Google Shape;339;p16"/>
           <p:cNvSpPr txBox="1"/>
           <p:nvPr/>
         </p:nvSpPr>
@@ -23734,7 +23840,7 @@
       </p:sp>
       <p:sp>
         <p:nvSpPr>
-          <p:cNvPr id="338" name="Google Shape;338;p16"/>
+          <p:cNvPr id="340" name="Google Shape;340;p16"/>
           <p:cNvSpPr txBox="1"/>
           <p:nvPr/>
         </p:nvSpPr>
@@ -23787,7 +23893,7 @@
       </p:sp>
       <p:sp>
         <p:nvSpPr>
-          <p:cNvPr id="339" name="Google Shape;339;p16"/>
+          <p:cNvPr id="341" name="Google Shape;341;p16"/>
           <p:cNvSpPr txBox="1"/>
           <p:nvPr/>
         </p:nvSpPr>
@@ -23840,7 +23946,7 @@
       </p:sp>
       <p:sp>
         <p:nvSpPr>
-          <p:cNvPr id="340" name="Google Shape;340;p16"/>
+          <p:cNvPr id="342" name="Google Shape;342;p16"/>
           <p:cNvSpPr/>
           <p:nvPr/>
         </p:nvSpPr>
@@ -23899,7 +24005,7 @@
       </p:sp>
       <p:sp>
         <p:nvSpPr>
-          <p:cNvPr id="341" name="Google Shape;341;p16"/>
+          <p:cNvPr id="343" name="Google Shape;343;p16"/>
           <p:cNvSpPr/>
           <p:nvPr/>
         </p:nvSpPr>
@@ -23956,7 +24062,7 @@
       </p:sp>
       <p:sp>
         <p:nvSpPr>
-          <p:cNvPr id="342" name="Google Shape;342;p16"/>
+          <p:cNvPr id="344" name="Google Shape;344;p16"/>
           <p:cNvSpPr txBox="1"/>
           <p:nvPr/>
         </p:nvSpPr>
@@ -24009,7 +24115,7 @@
       </p:sp>
       <p:sp>
         <p:nvSpPr>
-          <p:cNvPr id="343" name="Google Shape;343;p16"/>
+          <p:cNvPr id="345" name="Google Shape;345;p16"/>
           <p:cNvSpPr txBox="1"/>
           <p:nvPr/>
         </p:nvSpPr>
@@ -24062,7 +24168,7 @@
       </p:sp>
       <p:sp>
         <p:nvSpPr>
-          <p:cNvPr id="344" name="Google Shape;344;p16"/>
+          <p:cNvPr id="346" name="Google Shape;346;p16"/>
           <p:cNvSpPr txBox="1"/>
           <p:nvPr/>
         </p:nvSpPr>
@@ -24115,7 +24221,7 @@
       </p:sp>
       <p:sp>
         <p:nvSpPr>
-          <p:cNvPr id="345" name="Google Shape;345;p16"/>
+          <p:cNvPr id="347" name="Google Shape;347;p16"/>
           <p:cNvSpPr/>
           <p:nvPr/>
         </p:nvSpPr>
@@ -24174,7 +24280,7 @@
       </p:sp>
       <p:sp>
         <p:nvSpPr>
-          <p:cNvPr id="346" name="Google Shape;346;p16"/>
+          <p:cNvPr id="348" name="Google Shape;348;p16"/>
           <p:cNvSpPr txBox="1"/>
           <p:nvPr/>
         </p:nvSpPr>
@@ -24239,7 +24345,7 @@
       </p:sp>
       <p:pic>
         <p:nvPicPr>
-          <p:cNvPr descr="garaza_logo.png" id="347" name="Google Shape;347;p16"/>
+          <p:cNvPr descr="garaza_logo.png" id="349" name="Google Shape;349;p16"/>
           <p:cNvPicPr preferRelativeResize="0"/>
           <p:nvPr/>
         </p:nvPicPr>
@@ -24266,7 +24372,7 @@
       </p:pic>
       <p:sp>
         <p:nvSpPr>
-          <p:cNvPr id="348" name="Google Shape;348;p16"/>
+          <p:cNvPr id="350" name="Google Shape;350;p16"/>
           <p:cNvSpPr txBox="1"/>
           <p:nvPr/>
         </p:nvSpPr>
@@ -24342,7 +24448,7 @@
   <p:cSld>
     <p:spTree>
       <p:nvGrpSpPr>
-        <p:cNvPr id="352" name="Shape 352"/>
+        <p:cNvPr id="354" name="Shape 354"/>
         <p:cNvGrpSpPr/>
         <p:nvPr/>
       </p:nvGrpSpPr>
@@ -24356,14 +24462,14 @@
       </p:grpSpPr>
       <p:sp>
         <p:nvSpPr>
-          <p:cNvPr id="353" name="Google Shape;353;p17"/>
-          <p:cNvSpPr/>
-          <p:nvPr/>
-        </p:nvSpPr>
-        <p:spPr>
-          <a:xfrm>
-            <a:off x="0" y="31060"/>
-            <a:ext cx="12191700" cy="6858000"/>
+          <p:cNvPr id="355" name="Google Shape;355;p17"/>
+          <p:cNvSpPr/>
+          <p:nvPr/>
+        </p:nvSpPr>
+        <p:spPr>
+          <a:xfrm>
+            <a:off x="0" y="0"/>
+            <a:ext cx="12191695" cy="6858000"/>
           </a:xfrm>
           <a:prstGeom prst="rect">
             <a:avLst/>
@@ -24407,7 +24513,7 @@
       </p:sp>
       <p:sp>
         <p:nvSpPr>
-          <p:cNvPr id="354" name="Google Shape;354;p17"/>
+          <p:cNvPr id="356" name="Google Shape;356;p17"/>
           <p:cNvSpPr/>
           <p:nvPr/>
         </p:nvSpPr>
@@ -24458,7 +24564,7 @@
       </p:sp>
       <p:sp>
         <p:nvSpPr>
-          <p:cNvPr id="355" name="Google Shape;355;p17"/>
+          <p:cNvPr id="357" name="Google Shape;357;p17"/>
           <p:cNvSpPr/>
           <p:nvPr/>
         </p:nvSpPr>
@@ -24509,7 +24615,7 @@
       </p:sp>
       <p:sp>
         <p:nvSpPr>
-          <p:cNvPr id="356" name="Google Shape;356;p17"/>
+          <p:cNvPr id="358" name="Google Shape;358;p17"/>
           <p:cNvSpPr/>
           <p:nvPr/>
         </p:nvSpPr>
@@ -24560,7 +24666,7 @@
       </p:sp>
       <p:sp>
         <p:nvSpPr>
-          <p:cNvPr id="357" name="Google Shape;357;p17"/>
+          <p:cNvPr id="359" name="Google Shape;359;p17"/>
           <p:cNvSpPr/>
           <p:nvPr/>
         </p:nvSpPr>
@@ -24611,7 +24717,7 @@
       </p:sp>
       <p:sp>
         <p:nvSpPr>
-          <p:cNvPr id="358" name="Google Shape;358;p17"/>
+          <p:cNvPr id="360" name="Google Shape;360;p17"/>
           <p:cNvSpPr/>
           <p:nvPr/>
         </p:nvSpPr>
@@ -24662,7 +24768,7 @@
       </p:sp>
       <p:sp>
         <p:nvSpPr>
-          <p:cNvPr id="359" name="Google Shape;359;p17"/>
+          <p:cNvPr id="361" name="Google Shape;361;p17"/>
           <p:cNvSpPr/>
           <p:nvPr/>
         </p:nvSpPr>
@@ -24713,7 +24819,7 @@
       </p:sp>
       <p:sp>
         <p:nvSpPr>
-          <p:cNvPr id="360" name="Google Shape;360;p17"/>
+          <p:cNvPr id="362" name="Google Shape;362;p17"/>
           <p:cNvSpPr/>
           <p:nvPr/>
         </p:nvSpPr>
@@ -24764,7 +24870,7 @@
       </p:sp>
       <p:sp>
         <p:nvSpPr>
-          <p:cNvPr id="361" name="Google Shape;361;p17"/>
+          <p:cNvPr id="363" name="Google Shape;363;p17"/>
           <p:cNvSpPr/>
           <p:nvPr/>
         </p:nvSpPr>
@@ -24815,7 +24921,7 @@
       </p:sp>
       <p:sp>
         <p:nvSpPr>
-          <p:cNvPr id="362" name="Google Shape;362;p17"/>
+          <p:cNvPr id="364" name="Google Shape;364;p17"/>
           <p:cNvSpPr/>
           <p:nvPr/>
         </p:nvSpPr>
@@ -24866,7 +24972,7 @@
       </p:sp>
       <p:sp>
         <p:nvSpPr>
-          <p:cNvPr id="363" name="Google Shape;363;p17"/>
+          <p:cNvPr id="365" name="Google Shape;365;p17"/>
           <p:cNvSpPr/>
           <p:nvPr/>
         </p:nvSpPr>
@@ -24917,7 +25023,7 @@
       </p:sp>
       <p:sp>
         <p:nvSpPr>
-          <p:cNvPr id="364" name="Google Shape;364;p17"/>
+          <p:cNvPr id="366" name="Google Shape;366;p17"/>
           <p:cNvSpPr/>
           <p:nvPr/>
         </p:nvSpPr>
@@ -24968,7 +25074,7 @@
       </p:sp>
       <p:sp>
         <p:nvSpPr>
-          <p:cNvPr id="365" name="Google Shape;365;p17"/>
+          <p:cNvPr id="367" name="Google Shape;367;p17"/>
           <p:cNvSpPr/>
           <p:nvPr/>
         </p:nvSpPr>
@@ -25019,7 +25125,7 @@
       </p:sp>
       <p:sp>
         <p:nvSpPr>
-          <p:cNvPr id="366" name="Google Shape;366;p17"/>
+          <p:cNvPr id="368" name="Google Shape;368;p17"/>
           <p:cNvSpPr/>
           <p:nvPr/>
         </p:nvSpPr>
@@ -25070,7 +25176,7 @@
       </p:sp>
       <p:sp>
         <p:nvSpPr>
-          <p:cNvPr id="367" name="Google Shape;367;p17"/>
+          <p:cNvPr id="369" name="Google Shape;369;p17"/>
           <p:cNvSpPr/>
           <p:nvPr/>
         </p:nvSpPr>
@@ -25121,7 +25227,7 @@
       </p:sp>
       <p:sp>
         <p:nvSpPr>
-          <p:cNvPr id="368" name="Google Shape;368;p17"/>
+          <p:cNvPr id="370" name="Google Shape;370;p17"/>
           <p:cNvSpPr/>
           <p:nvPr/>
         </p:nvSpPr>
@@ -25172,7 +25278,7 @@
       </p:sp>
       <p:sp>
         <p:nvSpPr>
-          <p:cNvPr id="369" name="Google Shape;369;p17"/>
+          <p:cNvPr id="371" name="Google Shape;371;p17"/>
           <p:cNvSpPr/>
           <p:nvPr/>
         </p:nvSpPr>
@@ -25223,7 +25329,7 @@
       </p:sp>
       <p:sp>
         <p:nvSpPr>
-          <p:cNvPr id="370" name="Google Shape;370;p17"/>
+          <p:cNvPr id="372" name="Google Shape;372;p17"/>
           <p:cNvSpPr/>
           <p:nvPr/>
         </p:nvSpPr>
@@ -25274,7 +25380,7 @@
       </p:sp>
       <p:sp>
         <p:nvSpPr>
-          <p:cNvPr id="371" name="Google Shape;371;p17"/>
+          <p:cNvPr id="373" name="Google Shape;373;p17"/>
           <p:cNvSpPr/>
           <p:nvPr/>
         </p:nvSpPr>
@@ -25325,7 +25431,7 @@
       </p:sp>
       <p:sp>
         <p:nvSpPr>
-          <p:cNvPr id="372" name="Google Shape;372;p17"/>
+          <p:cNvPr id="374" name="Google Shape;374;p17"/>
           <p:cNvSpPr/>
           <p:nvPr/>
         </p:nvSpPr>
@@ -25376,7 +25482,7 @@
       </p:sp>
       <p:sp>
         <p:nvSpPr>
-          <p:cNvPr id="373" name="Google Shape;373;p17"/>
+          <p:cNvPr id="375" name="Google Shape;375;p17"/>
           <p:cNvSpPr/>
           <p:nvPr/>
         </p:nvSpPr>
@@ -25427,7 +25533,7 @@
       </p:sp>
       <p:sp>
         <p:nvSpPr>
-          <p:cNvPr id="374" name="Google Shape;374;p17"/>
+          <p:cNvPr id="376" name="Google Shape;376;p17"/>
           <p:cNvSpPr/>
           <p:nvPr/>
         </p:nvSpPr>
@@ -25478,7 +25584,7 @@
       </p:sp>
       <p:sp>
         <p:nvSpPr>
-          <p:cNvPr id="375" name="Google Shape;375;p17"/>
+          <p:cNvPr id="377" name="Google Shape;377;p17"/>
           <p:cNvSpPr/>
           <p:nvPr/>
         </p:nvSpPr>
@@ -25529,7 +25635,7 @@
       </p:sp>
       <p:sp>
         <p:nvSpPr>
-          <p:cNvPr id="376" name="Google Shape;376;p17"/>
+          <p:cNvPr id="378" name="Google Shape;378;p17"/>
           <p:cNvSpPr/>
           <p:nvPr/>
         </p:nvSpPr>
@@ -25580,7 +25686,7 @@
       </p:sp>
       <p:sp>
         <p:nvSpPr>
-          <p:cNvPr id="377" name="Google Shape;377;p17"/>
+          <p:cNvPr id="379" name="Google Shape;379;p17"/>
           <p:cNvSpPr/>
           <p:nvPr/>
         </p:nvSpPr>
@@ -25631,7 +25737,7 @@
       </p:sp>
       <p:sp>
         <p:nvSpPr>
-          <p:cNvPr id="378" name="Google Shape;378;p17"/>
+          <p:cNvPr id="380" name="Google Shape;380;p17"/>
           <p:cNvSpPr/>
           <p:nvPr/>
         </p:nvSpPr>
@@ -25682,7 +25788,7 @@
       </p:sp>
       <p:sp>
         <p:nvSpPr>
-          <p:cNvPr id="379" name="Google Shape;379;p17"/>
+          <p:cNvPr id="381" name="Google Shape;381;p17"/>
           <p:cNvSpPr/>
           <p:nvPr/>
         </p:nvSpPr>
@@ -25733,7 +25839,7 @@
       </p:sp>
       <p:sp>
         <p:nvSpPr>
-          <p:cNvPr id="380" name="Google Shape;380;p17"/>
+          <p:cNvPr id="382" name="Google Shape;382;p17"/>
           <p:cNvSpPr/>
           <p:nvPr/>
         </p:nvSpPr>
@@ -25784,7 +25890,7 @@
       </p:sp>
       <p:sp>
         <p:nvSpPr>
-          <p:cNvPr id="381" name="Google Shape;381;p17"/>
+          <p:cNvPr id="383" name="Google Shape;383;p17"/>
           <p:cNvSpPr/>
           <p:nvPr/>
         </p:nvSpPr>
@@ -25835,7 +25941,7 @@
       </p:sp>
       <p:sp>
         <p:nvSpPr>
-          <p:cNvPr id="382" name="Google Shape;382;p17"/>
+          <p:cNvPr id="384" name="Google Shape;384;p17"/>
           <p:cNvSpPr/>
           <p:nvPr/>
         </p:nvSpPr>
@@ -25886,7 +25992,7 @@
       </p:sp>
       <p:sp>
         <p:nvSpPr>
-          <p:cNvPr id="383" name="Google Shape;383;p17"/>
+          <p:cNvPr id="385" name="Google Shape;385;p17"/>
           <p:cNvSpPr/>
           <p:nvPr/>
         </p:nvSpPr>
@@ -25937,7 +26043,7 @@
       </p:sp>
       <p:sp>
         <p:nvSpPr>
-          <p:cNvPr id="384" name="Google Shape;384;p17"/>
+          <p:cNvPr id="386" name="Google Shape;386;p17"/>
           <p:cNvSpPr/>
           <p:nvPr/>
         </p:nvSpPr>
@@ -25988,7 +26094,7 @@
       </p:sp>
       <p:sp>
         <p:nvSpPr>
-          <p:cNvPr id="385" name="Google Shape;385;p17"/>
+          <p:cNvPr id="387" name="Google Shape;387;p17"/>
           <p:cNvSpPr/>
           <p:nvPr/>
         </p:nvSpPr>
@@ -26039,7 +26145,7 @@
       </p:sp>
       <p:sp>
         <p:nvSpPr>
-          <p:cNvPr id="386" name="Google Shape;386;p17"/>
+          <p:cNvPr id="388" name="Google Shape;388;p17"/>
           <p:cNvSpPr/>
           <p:nvPr/>
         </p:nvSpPr>
@@ -26090,7 +26196,7 @@
       </p:sp>
       <p:sp>
         <p:nvSpPr>
-          <p:cNvPr id="387" name="Google Shape;387;p17"/>
+          <p:cNvPr id="389" name="Google Shape;389;p17"/>
           <p:cNvSpPr/>
           <p:nvPr/>
         </p:nvSpPr>
@@ -26141,7 +26247,7 @@
       </p:sp>
       <p:sp>
         <p:nvSpPr>
-          <p:cNvPr id="388" name="Google Shape;388;p17"/>
+          <p:cNvPr id="390" name="Google Shape;390;p17"/>
           <p:cNvSpPr/>
           <p:nvPr/>
         </p:nvSpPr>
@@ -26192,7 +26298,7 @@
       </p:sp>
       <p:sp>
         <p:nvSpPr>
-          <p:cNvPr id="389" name="Google Shape;389;p17"/>
+          <p:cNvPr id="391" name="Google Shape;391;p17"/>
           <p:cNvSpPr/>
           <p:nvPr/>
         </p:nvSpPr>
@@ -26243,7 +26349,7 @@
       </p:sp>
       <p:sp>
         <p:nvSpPr>
-          <p:cNvPr id="390" name="Google Shape;390;p17"/>
+          <p:cNvPr id="392" name="Google Shape;392;p17"/>
           <p:cNvSpPr/>
           <p:nvPr/>
         </p:nvSpPr>
@@ -26294,7 +26400,7 @@
       </p:sp>
       <p:sp>
         <p:nvSpPr>
-          <p:cNvPr id="391" name="Google Shape;391;p17"/>
+          <p:cNvPr id="393" name="Google Shape;393;p17"/>
           <p:cNvSpPr/>
           <p:nvPr/>
         </p:nvSpPr>
@@ -26345,7 +26451,7 @@
       </p:sp>
       <p:sp>
         <p:nvSpPr>
-          <p:cNvPr id="392" name="Google Shape;392;p17"/>
+          <p:cNvPr id="394" name="Google Shape;394;p17"/>
           <p:cNvSpPr/>
           <p:nvPr/>
         </p:nvSpPr>
@@ -26396,7 +26502,7 @@
       </p:sp>
       <p:sp>
         <p:nvSpPr>
-          <p:cNvPr id="393" name="Google Shape;393;p17"/>
+          <p:cNvPr id="395" name="Google Shape;395;p17"/>
           <p:cNvSpPr/>
           <p:nvPr/>
         </p:nvSpPr>
@@ -26447,7 +26553,7 @@
       </p:sp>
       <p:sp>
         <p:nvSpPr>
-          <p:cNvPr id="394" name="Google Shape;394;p17"/>
+          <p:cNvPr id="396" name="Google Shape;396;p17"/>
           <p:cNvSpPr/>
           <p:nvPr/>
         </p:nvSpPr>
@@ -26498,7 +26604,7 @@
       </p:sp>
       <p:sp>
         <p:nvSpPr>
-          <p:cNvPr id="395" name="Google Shape;395;p17"/>
+          <p:cNvPr id="397" name="Google Shape;397;p17"/>
           <p:cNvSpPr/>
           <p:nvPr/>
         </p:nvSpPr>
@@ -26549,7 +26655,7 @@
       </p:sp>
       <p:sp>
         <p:nvSpPr>
-          <p:cNvPr id="396" name="Google Shape;396;p17"/>
+          <p:cNvPr id="398" name="Google Shape;398;p17"/>
           <p:cNvSpPr/>
           <p:nvPr/>
         </p:nvSpPr>
@@ -26600,7 +26706,7 @@
       </p:sp>
       <p:sp>
         <p:nvSpPr>
-          <p:cNvPr id="397" name="Google Shape;397;p17"/>
+          <p:cNvPr id="399" name="Google Shape;399;p17"/>
           <p:cNvSpPr/>
           <p:nvPr/>
         </p:nvSpPr>
@@ -26651,7 +26757,7 @@
       </p:sp>
       <p:sp>
         <p:nvSpPr>
-          <p:cNvPr id="398" name="Google Shape;398;p17"/>
+          <p:cNvPr id="400" name="Google Shape;400;p17"/>
           <p:cNvSpPr txBox="1"/>
           <p:nvPr/>
         </p:nvSpPr>
@@ -26716,7 +26822,7 @@
       </p:sp>
       <p:sp>
         <p:nvSpPr>
-          <p:cNvPr id="399" name="Google Shape;399;p17"/>
+          <p:cNvPr id="401" name="Google Shape;401;p17"/>
           <p:cNvSpPr txBox="1"/>
           <p:nvPr/>
         </p:nvSpPr>
@@ -26769,7 +26875,7 @@
       </p:sp>
       <p:sp>
         <p:nvSpPr>
-          <p:cNvPr id="400" name="Google Shape;400;p17"/>
+          <p:cNvPr id="402" name="Google Shape;402;p17"/>
           <p:cNvSpPr/>
           <p:nvPr/>
         </p:nvSpPr>
@@ -26828,7 +26934,7 @@
       </p:sp>
       <p:sp>
         <p:nvSpPr>
-          <p:cNvPr id="401" name="Google Shape;401;p17"/>
+          <p:cNvPr id="403" name="Google Shape;403;p17"/>
           <p:cNvSpPr/>
           <p:nvPr/>
         </p:nvSpPr>
@@ -26879,7 +26985,7 @@
       </p:sp>
       <p:sp>
         <p:nvSpPr>
-          <p:cNvPr id="402" name="Google Shape;402;p17"/>
+          <p:cNvPr id="404" name="Google Shape;404;p17"/>
           <p:cNvSpPr txBox="1"/>
           <p:nvPr/>
         </p:nvSpPr>
@@ -26932,7 +27038,7 @@
       </p:sp>
       <p:sp>
         <p:nvSpPr>
-          <p:cNvPr id="403" name="Google Shape;403;p17"/>
+          <p:cNvPr id="405" name="Google Shape;405;p17"/>
           <p:cNvSpPr txBox="1"/>
           <p:nvPr/>
         </p:nvSpPr>
@@ -26985,7 +27091,7 @@
       </p:sp>
       <p:sp>
         <p:nvSpPr>
-          <p:cNvPr id="404" name="Google Shape;404;p17"/>
+          <p:cNvPr id="406" name="Google Shape;406;p17"/>
           <p:cNvSpPr txBox="1"/>
           <p:nvPr/>
         </p:nvSpPr>
@@ -27038,7 +27144,7 @@
       </p:sp>
       <p:sp>
         <p:nvSpPr>
-          <p:cNvPr id="405" name="Google Shape;405;p17"/>
+          <p:cNvPr id="407" name="Google Shape;407;p17"/>
           <p:cNvSpPr/>
           <p:nvPr/>
         </p:nvSpPr>
@@ -27097,7 +27203,7 @@
       </p:sp>
       <p:sp>
         <p:nvSpPr>
-          <p:cNvPr id="406" name="Google Shape;406;p17"/>
+          <p:cNvPr id="408" name="Google Shape;408;p17"/>
           <p:cNvSpPr/>
           <p:nvPr/>
         </p:nvSpPr>
@@ -27148,7 +27254,7 @@
       </p:sp>
       <p:sp>
         <p:nvSpPr>
-          <p:cNvPr id="407" name="Google Shape;407;p17"/>
+          <p:cNvPr id="409" name="Google Shape;409;p17"/>
           <p:cNvSpPr txBox="1"/>
           <p:nvPr/>
         </p:nvSpPr>
@@ -27201,7 +27307,7 @@
       </p:sp>
       <p:sp>
         <p:nvSpPr>
-          <p:cNvPr id="408" name="Google Shape;408;p17"/>
+          <p:cNvPr id="410" name="Google Shape;410;p17"/>
           <p:cNvSpPr txBox="1"/>
           <p:nvPr/>
         </p:nvSpPr>
@@ -27254,7 +27360,7 @@
       </p:sp>
       <p:sp>
         <p:nvSpPr>
-          <p:cNvPr id="409" name="Google Shape;409;p17"/>
+          <p:cNvPr id="411" name="Google Shape;411;p17"/>
           <p:cNvSpPr txBox="1"/>
           <p:nvPr/>
         </p:nvSpPr>
@@ -27307,7 +27413,7 @@
       </p:sp>
       <p:sp>
         <p:nvSpPr>
-          <p:cNvPr id="410" name="Google Shape;410;p17"/>
+          <p:cNvPr id="412" name="Google Shape;412;p17"/>
           <p:cNvSpPr/>
           <p:nvPr/>
         </p:nvSpPr>
@@ -27366,7 +27472,7 @@
       </p:sp>
       <p:sp>
         <p:nvSpPr>
-          <p:cNvPr id="411" name="Google Shape;411;p17"/>
+          <p:cNvPr id="413" name="Google Shape;413;p17"/>
           <p:cNvSpPr/>
           <p:nvPr/>
         </p:nvSpPr>
@@ -27417,7 +27523,7 @@
       </p:sp>
       <p:sp>
         <p:nvSpPr>
-          <p:cNvPr id="412" name="Google Shape;412;p17"/>
+          <p:cNvPr id="414" name="Google Shape;414;p17"/>
           <p:cNvSpPr txBox="1"/>
           <p:nvPr/>
         </p:nvSpPr>
@@ -27470,7 +27576,7 @@
       </p:sp>
       <p:sp>
         <p:nvSpPr>
-          <p:cNvPr id="413" name="Google Shape;413;p17"/>
+          <p:cNvPr id="415" name="Google Shape;415;p17"/>
           <p:cNvSpPr txBox="1"/>
           <p:nvPr/>
         </p:nvSpPr>
@@ -27523,7 +27629,7 @@
       </p:sp>
       <p:sp>
         <p:nvSpPr>
-          <p:cNvPr id="414" name="Google Shape;414;p17"/>
+          <p:cNvPr id="416" name="Google Shape;416;p17"/>
           <p:cNvSpPr txBox="1"/>
           <p:nvPr/>
         </p:nvSpPr>
@@ -27576,7 +27682,7 @@
       </p:sp>
       <p:sp>
         <p:nvSpPr>
-          <p:cNvPr id="415" name="Google Shape;415;p17"/>
+          <p:cNvPr id="417" name="Google Shape;417;p17"/>
           <p:cNvSpPr/>
           <p:nvPr/>
         </p:nvSpPr>
@@ -27635,7 +27741,7 @@
       </p:sp>
       <p:sp>
         <p:nvSpPr>
-          <p:cNvPr id="416" name="Google Shape;416;p17"/>
+          <p:cNvPr id="418" name="Google Shape;418;p17"/>
           <p:cNvSpPr/>
           <p:nvPr/>
         </p:nvSpPr>
@@ -27686,7 +27792,7 @@
       </p:sp>
       <p:sp>
         <p:nvSpPr>
-          <p:cNvPr id="417" name="Google Shape;417;p17"/>
+          <p:cNvPr id="419" name="Google Shape;419;p17"/>
           <p:cNvSpPr txBox="1"/>
           <p:nvPr/>
         </p:nvSpPr>
@@ -27739,7 +27845,7 @@
       </p:sp>
       <p:sp>
         <p:nvSpPr>
-          <p:cNvPr id="418" name="Google Shape;418;p17"/>
+          <p:cNvPr id="420" name="Google Shape;420;p17"/>
           <p:cNvSpPr txBox="1"/>
           <p:nvPr/>
         </p:nvSpPr>
@@ -27792,7 +27898,7 @@
       </p:sp>
       <p:sp>
         <p:nvSpPr>
-          <p:cNvPr id="419" name="Google Shape;419;p17"/>
+          <p:cNvPr id="421" name="Google Shape;421;p17"/>
           <p:cNvSpPr txBox="1"/>
           <p:nvPr/>
         </p:nvSpPr>
@@ -27845,7 +27951,7 @@
       </p:sp>
       <p:sp>
         <p:nvSpPr>
-          <p:cNvPr id="420" name="Google Shape;420;p17"/>
+          <p:cNvPr id="422" name="Google Shape;422;p17"/>
           <p:cNvSpPr/>
           <p:nvPr/>
         </p:nvSpPr>
@@ -27904,7 +28010,7 @@
       </p:sp>
       <p:sp>
         <p:nvSpPr>
-          <p:cNvPr id="421" name="Google Shape;421;p17"/>
+          <p:cNvPr id="423" name="Google Shape;423;p17"/>
           <p:cNvSpPr/>
           <p:nvPr/>
         </p:nvSpPr>
@@ -27955,7 +28061,7 @@
       </p:sp>
       <p:sp>
         <p:nvSpPr>
-          <p:cNvPr id="422" name="Google Shape;422;p17"/>
+          <p:cNvPr id="424" name="Google Shape;424;p17"/>
           <p:cNvSpPr txBox="1"/>
           <p:nvPr/>
         </p:nvSpPr>
@@ -28008,7 +28114,7 @@
       </p:sp>
       <p:sp>
         <p:nvSpPr>
-          <p:cNvPr id="423" name="Google Shape;423;p17"/>
+          <p:cNvPr id="425" name="Google Shape;425;p17"/>
           <p:cNvSpPr txBox="1"/>
           <p:nvPr/>
         </p:nvSpPr>
@@ -28061,7 +28167,7 @@
       </p:sp>
       <p:sp>
         <p:nvSpPr>
-          <p:cNvPr id="424" name="Google Shape;424;p17"/>
+          <p:cNvPr id="426" name="Google Shape;426;p17"/>
           <p:cNvSpPr txBox="1"/>
           <p:nvPr/>
         </p:nvSpPr>
@@ -28114,7 +28220,7 @@
       </p:sp>
       <p:sp>
         <p:nvSpPr>
-          <p:cNvPr id="425" name="Google Shape;425;p17"/>
+          <p:cNvPr id="427" name="Google Shape;427;p17"/>
           <p:cNvSpPr/>
           <p:nvPr/>
         </p:nvSpPr>
@@ -28173,7 +28279,7 @@
       </p:sp>
       <p:sp>
         <p:nvSpPr>
-          <p:cNvPr id="426" name="Google Shape;426;p17"/>
+          <p:cNvPr id="428" name="Google Shape;428;p17"/>
           <p:cNvSpPr/>
           <p:nvPr/>
         </p:nvSpPr>
@@ -28224,7 +28330,7 @@
       </p:sp>
       <p:sp>
         <p:nvSpPr>
-          <p:cNvPr id="427" name="Google Shape;427;p17"/>
+          <p:cNvPr id="429" name="Google Shape;429;p17"/>
           <p:cNvSpPr txBox="1"/>
           <p:nvPr/>
         </p:nvSpPr>
@@ -28277,7 +28383,7 @@
       </p:sp>
       <p:sp>
         <p:nvSpPr>
-          <p:cNvPr id="428" name="Google Shape;428;p17"/>
+          <p:cNvPr id="430" name="Google Shape;430;p17"/>
           <p:cNvSpPr txBox="1"/>
           <p:nvPr/>
         </p:nvSpPr>
@@ -28330,7 +28436,7 @@
       </p:sp>
       <p:sp>
         <p:nvSpPr>
-          <p:cNvPr id="429" name="Google Shape;429;p17"/>
+          <p:cNvPr id="431" name="Google Shape;431;p17"/>
           <p:cNvSpPr txBox="1"/>
           <p:nvPr/>
         </p:nvSpPr>
@@ -28383,7 +28489,7 @@
       </p:sp>
       <p:sp>
         <p:nvSpPr>
-          <p:cNvPr id="430" name="Google Shape;430;p17"/>
+          <p:cNvPr id="432" name="Google Shape;432;p17"/>
           <p:cNvSpPr txBox="1"/>
           <p:nvPr/>
         </p:nvSpPr>
@@ -28447,7 +28553,7 @@
   <p:cSld>
     <p:spTree>
       <p:nvGrpSpPr>
-        <p:cNvPr id="434" name="Shape 434"/>
+        <p:cNvPr id="436" name="Shape 436"/>
         <p:cNvGrpSpPr/>
         <p:nvPr/>
       </p:nvGrpSpPr>
@@ -28461,7 +28567,7 @@
       </p:grpSpPr>
       <p:sp>
         <p:nvSpPr>
-          <p:cNvPr id="435" name="Google Shape;435;p18"/>
+          <p:cNvPr id="437" name="Google Shape;437;p18"/>
           <p:cNvSpPr/>
           <p:nvPr/>
         </p:nvSpPr>
@@ -28512,7 +28618,7 @@
       </p:sp>
       <p:sp>
         <p:nvSpPr>
-          <p:cNvPr id="436" name="Google Shape;436;p18"/>
+          <p:cNvPr id="438" name="Google Shape;438;p18"/>
           <p:cNvSpPr/>
           <p:nvPr/>
         </p:nvSpPr>
@@ -28563,7 +28669,7 @@
       </p:sp>
       <p:sp>
         <p:nvSpPr>
-          <p:cNvPr id="437" name="Google Shape;437;p18"/>
+          <p:cNvPr id="439" name="Google Shape;439;p18"/>
           <p:cNvSpPr/>
           <p:nvPr/>
         </p:nvSpPr>
@@ -28614,7 +28720,7 @@
       </p:sp>
       <p:sp>
         <p:nvSpPr>
-          <p:cNvPr id="438" name="Google Shape;438;p18"/>
+          <p:cNvPr id="440" name="Google Shape;440;p18"/>
           <p:cNvSpPr/>
           <p:nvPr/>
         </p:nvSpPr>
@@ -28665,7 +28771,7 @@
       </p:sp>
       <p:sp>
         <p:nvSpPr>
-          <p:cNvPr id="439" name="Google Shape;439;p18"/>
+          <p:cNvPr id="441" name="Google Shape;441;p18"/>
           <p:cNvSpPr/>
           <p:nvPr/>
         </p:nvSpPr>
@@ -28716,7 +28822,7 @@
       </p:sp>
       <p:sp>
         <p:nvSpPr>
-          <p:cNvPr id="440" name="Google Shape;440;p18"/>
+          <p:cNvPr id="442" name="Google Shape;442;p18"/>
           <p:cNvSpPr/>
           <p:nvPr/>
         </p:nvSpPr>
@@ -28767,7 +28873,7 @@
       </p:sp>
       <p:sp>
         <p:nvSpPr>
-          <p:cNvPr id="441" name="Google Shape;441;p18"/>
+          <p:cNvPr id="443" name="Google Shape;443;p18"/>
           <p:cNvSpPr/>
           <p:nvPr/>
         </p:nvSpPr>
@@ -28818,7 +28924,7 @@
       </p:sp>
       <p:sp>
         <p:nvSpPr>
-          <p:cNvPr id="442" name="Google Shape;442;p18"/>
+          <p:cNvPr id="444" name="Google Shape;444;p18"/>
           <p:cNvSpPr/>
           <p:nvPr/>
         </p:nvSpPr>
@@ -28869,7 +28975,7 @@
       </p:sp>
       <p:sp>
         <p:nvSpPr>
-          <p:cNvPr id="443" name="Google Shape;443;p18"/>
+          <p:cNvPr id="445" name="Google Shape;445;p18"/>
           <p:cNvSpPr/>
           <p:nvPr/>
         </p:nvSpPr>
@@ -28920,7 +29026,7 @@
       </p:sp>
       <p:sp>
         <p:nvSpPr>
-          <p:cNvPr id="444" name="Google Shape;444;p18"/>
+          <p:cNvPr id="446" name="Google Shape;446;p18"/>
           <p:cNvSpPr/>
           <p:nvPr/>
         </p:nvSpPr>
@@ -28971,7 +29077,7 @@
       </p:sp>
       <p:sp>
         <p:nvSpPr>
-          <p:cNvPr id="445" name="Google Shape;445;p18"/>
+          <p:cNvPr id="447" name="Google Shape;447;p18"/>
           <p:cNvSpPr/>
           <p:nvPr/>
         </p:nvSpPr>
@@ -29022,7 +29128,7 @@
       </p:sp>
       <p:sp>
         <p:nvSpPr>
-          <p:cNvPr id="446" name="Google Shape;446;p18"/>
+          <p:cNvPr id="448" name="Google Shape;448;p18"/>
           <p:cNvSpPr/>
           <p:nvPr/>
         </p:nvSpPr>
@@ -29073,7 +29179,7 @@
       </p:sp>
       <p:sp>
         <p:nvSpPr>
-          <p:cNvPr id="447" name="Google Shape;447;p18"/>
+          <p:cNvPr id="449" name="Google Shape;449;p18"/>
           <p:cNvSpPr/>
           <p:nvPr/>
         </p:nvSpPr>
@@ -29124,7 +29230,7 @@
       </p:sp>
       <p:sp>
         <p:nvSpPr>
-          <p:cNvPr id="448" name="Google Shape;448;p18"/>
+          <p:cNvPr id="450" name="Google Shape;450;p18"/>
           <p:cNvSpPr/>
           <p:nvPr/>
         </p:nvSpPr>
@@ -29175,7 +29281,7 @@
       </p:sp>
       <p:sp>
         <p:nvSpPr>
-          <p:cNvPr id="449" name="Google Shape;449;p18"/>
+          <p:cNvPr id="451" name="Google Shape;451;p18"/>
           <p:cNvSpPr/>
           <p:nvPr/>
         </p:nvSpPr>
@@ -29226,7 +29332,7 @@
       </p:sp>
       <p:sp>
         <p:nvSpPr>
-          <p:cNvPr id="450" name="Google Shape;450;p18"/>
+          <p:cNvPr id="452" name="Google Shape;452;p18"/>
           <p:cNvSpPr/>
           <p:nvPr/>
         </p:nvSpPr>
@@ -29277,7 +29383,7 @@
       </p:sp>
       <p:sp>
         <p:nvSpPr>
-          <p:cNvPr id="451" name="Google Shape;451;p18"/>
+          <p:cNvPr id="453" name="Google Shape;453;p18"/>
           <p:cNvSpPr/>
           <p:nvPr/>
         </p:nvSpPr>
@@ -29328,7 +29434,7 @@
       </p:sp>
       <p:sp>
         <p:nvSpPr>
-          <p:cNvPr id="452" name="Google Shape;452;p18"/>
+          <p:cNvPr id="454" name="Google Shape;454;p18"/>
           <p:cNvSpPr/>
           <p:nvPr/>
         </p:nvSpPr>
@@ -29379,7 +29485,7 @@
       </p:sp>
       <p:sp>
         <p:nvSpPr>
-          <p:cNvPr id="453" name="Google Shape;453;p18"/>
+          <p:cNvPr id="455" name="Google Shape;455;p18"/>
           <p:cNvSpPr/>
           <p:nvPr/>
         </p:nvSpPr>
@@ -29430,7 +29536,7 @@
       </p:sp>
       <p:sp>
         <p:nvSpPr>
-          <p:cNvPr id="454" name="Google Shape;454;p18"/>
+          <p:cNvPr id="456" name="Google Shape;456;p18"/>
           <p:cNvSpPr/>
           <p:nvPr/>
         </p:nvSpPr>
@@ -29481,7 +29587,7 @@
       </p:sp>
       <p:sp>
         <p:nvSpPr>
-          <p:cNvPr id="455" name="Google Shape;455;p18"/>
+          <p:cNvPr id="457" name="Google Shape;457;p18"/>
           <p:cNvSpPr/>
           <p:nvPr/>
         </p:nvSpPr>
@@ -29532,7 +29638,7 @@
       </p:sp>
       <p:sp>
         <p:nvSpPr>
-          <p:cNvPr id="456" name="Google Shape;456;p18"/>
+          <p:cNvPr id="458" name="Google Shape;458;p18"/>
           <p:cNvSpPr/>
           <p:nvPr/>
         </p:nvSpPr>
@@ -29583,7 +29689,7 @@
       </p:sp>
       <p:sp>
         <p:nvSpPr>
-          <p:cNvPr id="457" name="Google Shape;457;p18"/>
+          <p:cNvPr id="459" name="Google Shape;459;p18"/>
           <p:cNvSpPr/>
           <p:nvPr/>
         </p:nvSpPr>
@@ -29634,7 +29740,7 @@
       </p:sp>
       <p:sp>
         <p:nvSpPr>
-          <p:cNvPr id="458" name="Google Shape;458;p18"/>
+          <p:cNvPr id="460" name="Google Shape;460;p18"/>
           <p:cNvSpPr/>
           <p:nvPr/>
         </p:nvSpPr>
@@ -29685,7 +29791,7 @@
       </p:sp>
       <p:sp>
         <p:nvSpPr>
-          <p:cNvPr id="459" name="Google Shape;459;p18"/>
+          <p:cNvPr id="461" name="Google Shape;461;p18"/>
           <p:cNvSpPr/>
           <p:nvPr/>
         </p:nvSpPr>
@@ -29736,7 +29842,7 @@
       </p:sp>
       <p:sp>
         <p:nvSpPr>
-          <p:cNvPr id="460" name="Google Shape;460;p18"/>
+          <p:cNvPr id="462" name="Google Shape;462;p18"/>
           <p:cNvSpPr/>
           <p:nvPr/>
         </p:nvSpPr>
@@ -29787,7 +29893,7 @@
       </p:sp>
       <p:sp>
         <p:nvSpPr>
-          <p:cNvPr id="461" name="Google Shape;461;p18"/>
+          <p:cNvPr id="463" name="Google Shape;463;p18"/>
           <p:cNvSpPr/>
           <p:nvPr/>
         </p:nvSpPr>
@@ -29838,7 +29944,7 @@
       </p:sp>
       <p:sp>
         <p:nvSpPr>
-          <p:cNvPr id="462" name="Google Shape;462;p18"/>
+          <p:cNvPr id="464" name="Google Shape;464;p18"/>
           <p:cNvSpPr/>
           <p:nvPr/>
         </p:nvSpPr>
@@ -29889,7 +29995,7 @@
       </p:sp>
       <p:sp>
         <p:nvSpPr>
-          <p:cNvPr id="463" name="Google Shape;463;p18"/>
+          <p:cNvPr id="465" name="Google Shape;465;p18"/>
           <p:cNvSpPr/>
           <p:nvPr/>
         </p:nvSpPr>
@@ -29940,7 +30046,7 @@
       </p:sp>
       <p:sp>
         <p:nvSpPr>
-          <p:cNvPr id="464" name="Google Shape;464;p18"/>
+          <p:cNvPr id="466" name="Google Shape;466;p18"/>
           <p:cNvSpPr/>
           <p:nvPr/>
         </p:nvSpPr>
@@ -29991,7 +30097,7 @@
       </p:sp>
       <p:sp>
         <p:nvSpPr>
-          <p:cNvPr id="465" name="Google Shape;465;p18"/>
+          <p:cNvPr id="467" name="Google Shape;467;p18"/>
           <p:cNvSpPr/>
           <p:nvPr/>
         </p:nvSpPr>
@@ -30042,7 +30148,7 @@
       </p:sp>
       <p:sp>
         <p:nvSpPr>
-          <p:cNvPr id="466" name="Google Shape;466;p18"/>
+          <p:cNvPr id="468" name="Google Shape;468;p18"/>
           <p:cNvSpPr/>
           <p:nvPr/>
         </p:nvSpPr>
@@ -30093,7 +30199,7 @@
       </p:sp>
       <p:sp>
         <p:nvSpPr>
-          <p:cNvPr id="467" name="Google Shape;467;p18"/>
+          <p:cNvPr id="469" name="Google Shape;469;p18"/>
           <p:cNvSpPr/>
           <p:nvPr/>
         </p:nvSpPr>
@@ -30144,7 +30250,7 @@
       </p:sp>
       <p:sp>
         <p:nvSpPr>
-          <p:cNvPr id="468" name="Google Shape;468;p18"/>
+          <p:cNvPr id="470" name="Google Shape;470;p18"/>
           <p:cNvSpPr/>
           <p:nvPr/>
         </p:nvSpPr>
@@ -30195,7 +30301,7 @@
       </p:sp>
       <p:sp>
         <p:nvSpPr>
-          <p:cNvPr id="469" name="Google Shape;469;p18"/>
+          <p:cNvPr id="471" name="Google Shape;471;p18"/>
           <p:cNvSpPr/>
           <p:nvPr/>
         </p:nvSpPr>
@@ -30246,7 +30352,7 @@
       </p:sp>
       <p:sp>
         <p:nvSpPr>
-          <p:cNvPr id="470" name="Google Shape;470;p18"/>
+          <p:cNvPr id="472" name="Google Shape;472;p18"/>
           <p:cNvSpPr/>
           <p:nvPr/>
         </p:nvSpPr>
@@ -30297,7 +30403,7 @@
       </p:sp>
       <p:sp>
         <p:nvSpPr>
-          <p:cNvPr id="471" name="Google Shape;471;p18"/>
+          <p:cNvPr id="473" name="Google Shape;473;p18"/>
           <p:cNvSpPr/>
           <p:nvPr/>
         </p:nvSpPr>
@@ -30348,7 +30454,7 @@
       </p:sp>
       <p:sp>
         <p:nvSpPr>
-          <p:cNvPr id="472" name="Google Shape;472;p18"/>
+          <p:cNvPr id="474" name="Google Shape;474;p18"/>
           <p:cNvSpPr/>
           <p:nvPr/>
         </p:nvSpPr>
@@ -30399,7 +30505,7 @@
       </p:sp>
       <p:sp>
         <p:nvSpPr>
-          <p:cNvPr id="473" name="Google Shape;473;p18"/>
+          <p:cNvPr id="475" name="Google Shape;475;p18"/>
           <p:cNvSpPr/>
           <p:nvPr/>
         </p:nvSpPr>
@@ -30450,7 +30556,7 @@
       </p:sp>
       <p:sp>
         <p:nvSpPr>
-          <p:cNvPr id="474" name="Google Shape;474;p18"/>
+          <p:cNvPr id="476" name="Google Shape;476;p18"/>
           <p:cNvSpPr/>
           <p:nvPr/>
         </p:nvSpPr>
@@ -30501,7 +30607,7 @@
       </p:sp>
       <p:sp>
         <p:nvSpPr>
-          <p:cNvPr id="475" name="Google Shape;475;p18"/>
+          <p:cNvPr id="477" name="Google Shape;477;p18"/>
           <p:cNvSpPr/>
           <p:nvPr/>
         </p:nvSpPr>
@@ -30552,7 +30658,7 @@
       </p:sp>
       <p:sp>
         <p:nvSpPr>
-          <p:cNvPr id="476" name="Google Shape;476;p18"/>
+          <p:cNvPr id="478" name="Google Shape;478;p18"/>
           <p:cNvSpPr/>
           <p:nvPr/>
         </p:nvSpPr>
@@ -30603,7 +30709,7 @@
       </p:sp>
       <p:sp>
         <p:nvSpPr>
-          <p:cNvPr id="477" name="Google Shape;477;p18"/>
+          <p:cNvPr id="479" name="Google Shape;479;p18"/>
           <p:cNvSpPr/>
           <p:nvPr/>
         </p:nvSpPr>
@@ -30654,7 +30760,7 @@
       </p:sp>
       <p:sp>
         <p:nvSpPr>
-          <p:cNvPr id="478" name="Google Shape;478;p18"/>
+          <p:cNvPr id="480" name="Google Shape;480;p18"/>
           <p:cNvSpPr/>
           <p:nvPr/>
         </p:nvSpPr>
@@ -30705,7 +30811,7 @@
       </p:sp>
       <p:sp>
         <p:nvSpPr>
-          <p:cNvPr id="479" name="Google Shape;479;p18"/>
+          <p:cNvPr id="481" name="Google Shape;481;p18"/>
           <p:cNvSpPr/>
           <p:nvPr/>
         </p:nvSpPr>
@@ -30756,7 +30862,7 @@
       </p:sp>
       <p:sp>
         <p:nvSpPr>
-          <p:cNvPr id="480" name="Google Shape;480;p18"/>
+          <p:cNvPr id="482" name="Google Shape;482;p18"/>
           <p:cNvSpPr txBox="1"/>
           <p:nvPr/>
         </p:nvSpPr>
@@ -30821,7 +30927,7 @@
       </p:sp>
       <p:sp>
         <p:nvSpPr>
-          <p:cNvPr id="481" name="Google Shape;481;p18"/>
+          <p:cNvPr id="483" name="Google Shape;483;p18"/>
           <p:cNvSpPr txBox="1"/>
           <p:nvPr/>
         </p:nvSpPr>
@@ -30874,14 +30980,14 @@
       </p:sp>
       <p:sp>
         <p:nvSpPr>
-          <p:cNvPr id="482" name="Google Shape;482;p18"/>
-          <p:cNvSpPr/>
-          <p:nvPr/>
-        </p:nvSpPr>
-        <p:spPr>
-          <a:xfrm>
-            <a:off x="822960" y="2057400"/>
-            <a:ext cx="548640" cy="548640"/>
+          <p:cNvPr id="484" name="Google Shape;484;p18"/>
+          <p:cNvSpPr/>
+          <p:nvPr/>
+        </p:nvSpPr>
+        <p:spPr>
+          <a:xfrm>
+            <a:off x="822960" y="1901951"/>
+            <a:ext cx="512064" cy="512064"/>
           </a:xfrm>
           <a:prstGeom prst="ellipse">
             <a:avLst/>
@@ -30931,14 +31037,14 @@
       </p:sp>
       <p:sp>
         <p:nvSpPr>
-          <p:cNvPr id="483" name="Google Shape;483;p18"/>
+          <p:cNvPr id="485" name="Google Shape;485;p18"/>
           <p:cNvSpPr txBox="1"/>
           <p:nvPr/>
         </p:nvSpPr>
         <p:spPr>
           <a:xfrm>
-            <a:off x="822960" y="2029968"/>
-            <a:ext cx="548640" cy="566928"/>
+            <a:off x="822960" y="1874519"/>
+            <a:ext cx="512064" cy="548640"/>
           </a:xfrm>
           <a:prstGeom prst="rect">
             <a:avLst/>
@@ -30967,7 +31073,7 @@
               <a:buNone/>
             </a:pPr>
             <a:r>
-              <a:rPr b="0" i="0" lang="en-US" sz="2000" u="none" cap="none" strike="noStrike">
+              <a:rPr b="0" i="0" lang="en-US" sz="1800" u="none" cap="none" strike="noStrike">
                 <a:solidFill>
                   <a:srgbClr val="E8EDF6"/>
                 </a:solidFill>
@@ -30984,14 +31090,14 @@
       </p:sp>
       <p:sp>
         <p:nvSpPr>
-          <p:cNvPr id="484" name="Google Shape;484;p18"/>
+          <p:cNvPr id="486" name="Google Shape;486;p18"/>
           <p:cNvSpPr txBox="1"/>
           <p:nvPr/>
         </p:nvSpPr>
         <p:spPr>
           <a:xfrm>
-            <a:off x="1508760" y="2011680"/>
-            <a:ext cx="2286000" cy="640080"/>
+            <a:off x="1463040" y="1874519"/>
+            <a:ext cx="2286000" cy="566928"/>
           </a:xfrm>
           <a:prstGeom prst="rect">
             <a:avLst/>
@@ -31020,7 +31126,7 @@
               <a:buNone/>
             </a:pPr>
             <a:r>
-              <a:rPr b="1" i="0" lang="en-US" sz="1550" u="none" cap="none" strike="noStrike">
+              <a:rPr b="1" i="0" lang="en-US" sz="1500" u="none" cap="none" strike="noStrike">
                 <a:solidFill>
                   <a:srgbClr val="38BDF8"/>
                 </a:solidFill>
@@ -31037,14 +31143,14 @@
       </p:sp>
       <p:sp>
         <p:nvSpPr>
-          <p:cNvPr id="485" name="Google Shape;485;p18"/>
-          <p:cNvSpPr/>
-          <p:nvPr/>
-        </p:nvSpPr>
-        <p:spPr>
-          <a:xfrm>
-            <a:off x="3886200" y="2121408"/>
-            <a:ext cx="1174089" cy="420624"/>
+          <p:cNvPr id="487" name="Google Shape;487;p18"/>
+          <p:cNvSpPr/>
+          <p:nvPr/>
+        </p:nvSpPr>
+        <p:spPr>
+          <a:xfrm>
+            <a:off x="3840480" y="1947672"/>
+            <a:ext cx="1174089" cy="402336"/>
           </a:xfrm>
           <a:prstGeom prst="roundRect">
             <a:avLst>
@@ -31096,14 +31202,14 @@
       </p:sp>
       <p:sp>
         <p:nvSpPr>
-          <p:cNvPr id="486" name="Google Shape;486;p18"/>
+          <p:cNvPr id="488" name="Google Shape;488;p18"/>
           <p:cNvSpPr txBox="1"/>
           <p:nvPr/>
         </p:nvSpPr>
         <p:spPr>
           <a:xfrm>
-            <a:off x="3886200" y="2121408"/>
-            <a:ext cx="1174089" cy="420624"/>
+            <a:off x="3840480" y="1947672"/>
+            <a:ext cx="1174089" cy="402336"/>
           </a:xfrm>
           <a:prstGeom prst="rect">
             <a:avLst/>
@@ -31149,14 +31255,14 @@
       </p:sp>
       <p:sp>
         <p:nvSpPr>
-          <p:cNvPr id="487" name="Google Shape;487;p18"/>
-          <p:cNvSpPr/>
-          <p:nvPr/>
-        </p:nvSpPr>
-        <p:spPr>
-          <a:xfrm>
-            <a:off x="5224881" y="2121408"/>
-            <a:ext cx="1371600" cy="420624"/>
+          <p:cNvPr id="489" name="Google Shape;489;p18"/>
+          <p:cNvSpPr/>
+          <p:nvPr/>
+        </p:nvSpPr>
+        <p:spPr>
+          <a:xfrm>
+            <a:off x="5160873" y="1947672"/>
+            <a:ext cx="1371600" cy="402336"/>
           </a:xfrm>
           <a:prstGeom prst="roundRect">
             <a:avLst>
@@ -31208,14 +31314,14 @@
       </p:sp>
       <p:sp>
         <p:nvSpPr>
-          <p:cNvPr id="488" name="Google Shape;488;p18"/>
+          <p:cNvPr id="490" name="Google Shape;490;p18"/>
           <p:cNvSpPr txBox="1"/>
           <p:nvPr/>
         </p:nvSpPr>
         <p:spPr>
           <a:xfrm>
-            <a:off x="5224881" y="2121408"/>
-            <a:ext cx="1371600" cy="420624"/>
+            <a:off x="5160873" y="1947672"/>
+            <a:ext cx="1371600" cy="402336"/>
           </a:xfrm>
           <a:prstGeom prst="rect">
             <a:avLst/>
@@ -31261,14 +31367,14 @@
       </p:sp>
       <p:sp>
         <p:nvSpPr>
-          <p:cNvPr id="489" name="Google Shape;489;p18"/>
-          <p:cNvSpPr/>
-          <p:nvPr/>
-        </p:nvSpPr>
-        <p:spPr>
-          <a:xfrm>
-            <a:off x="6761073" y="2121408"/>
-            <a:ext cx="1766620" cy="420624"/>
+          <p:cNvPr id="491" name="Google Shape;491;p18"/>
+          <p:cNvSpPr/>
+          <p:nvPr/>
+        </p:nvSpPr>
+        <p:spPr>
+          <a:xfrm>
+            <a:off x="6678777" y="1947672"/>
+            <a:ext cx="1766620" cy="402336"/>
           </a:xfrm>
           <a:prstGeom prst="roundRect">
             <a:avLst>
@@ -31320,14 +31426,14 @@
       </p:sp>
       <p:sp>
         <p:nvSpPr>
-          <p:cNvPr id="490" name="Google Shape;490;p18"/>
+          <p:cNvPr id="492" name="Google Shape;492;p18"/>
           <p:cNvSpPr txBox="1"/>
           <p:nvPr/>
         </p:nvSpPr>
         <p:spPr>
           <a:xfrm>
-            <a:off x="6761073" y="2121408"/>
-            <a:ext cx="1766620" cy="420624"/>
+            <a:off x="6678777" y="1947672"/>
+            <a:ext cx="1766620" cy="402336"/>
           </a:xfrm>
           <a:prstGeom prst="rect">
             <a:avLst/>
@@ -31373,14 +31479,14 @@
       </p:sp>
       <p:sp>
         <p:nvSpPr>
-          <p:cNvPr id="491" name="Google Shape;491;p18"/>
-          <p:cNvSpPr/>
-          <p:nvPr/>
-        </p:nvSpPr>
-        <p:spPr>
-          <a:xfrm>
-            <a:off x="8692286" y="2121408"/>
-            <a:ext cx="1470355" cy="420624"/>
+          <p:cNvPr id="493" name="Google Shape;493;p18"/>
+          <p:cNvSpPr/>
+          <p:nvPr/>
+        </p:nvSpPr>
+        <p:spPr>
+          <a:xfrm>
+            <a:off x="8591702" y="1947672"/>
+            <a:ext cx="1470355" cy="402336"/>
           </a:xfrm>
           <a:prstGeom prst="roundRect">
             <a:avLst>
@@ -31432,14 +31538,14 @@
       </p:sp>
       <p:sp>
         <p:nvSpPr>
-          <p:cNvPr id="492" name="Google Shape;492;p18"/>
+          <p:cNvPr id="494" name="Google Shape;494;p18"/>
           <p:cNvSpPr txBox="1"/>
           <p:nvPr/>
         </p:nvSpPr>
         <p:spPr>
           <a:xfrm>
-            <a:off x="8692286" y="2121408"/>
-            <a:ext cx="1470355" cy="420624"/>
+            <a:off x="8591702" y="1947672"/>
+            <a:ext cx="1470355" cy="402336"/>
           </a:xfrm>
           <a:prstGeom prst="rect">
             <a:avLst/>
@@ -31485,14 +31591,14 @@
       </p:sp>
       <p:sp>
         <p:nvSpPr>
-          <p:cNvPr id="493" name="Google Shape;493;p18"/>
-          <p:cNvSpPr/>
-          <p:nvPr/>
-        </p:nvSpPr>
-        <p:spPr>
-          <a:xfrm>
-            <a:off x="822960" y="2880360"/>
-            <a:ext cx="548640" cy="548640"/>
+          <p:cNvPr id="495" name="Google Shape;495;p18"/>
+          <p:cNvSpPr/>
+          <p:nvPr/>
+        </p:nvSpPr>
+        <p:spPr>
+          <a:xfrm>
+            <a:off x="822960" y="2633471"/>
+            <a:ext cx="512064" cy="512064"/>
           </a:xfrm>
           <a:prstGeom prst="ellipse">
             <a:avLst/>
@@ -31542,14 +31648,14 @@
       </p:sp>
       <p:sp>
         <p:nvSpPr>
-          <p:cNvPr id="494" name="Google Shape;494;p18"/>
+          <p:cNvPr id="496" name="Google Shape;496;p18"/>
           <p:cNvSpPr txBox="1"/>
           <p:nvPr/>
         </p:nvSpPr>
         <p:spPr>
           <a:xfrm>
-            <a:off x="822960" y="2852928"/>
-            <a:ext cx="548640" cy="566928"/>
+            <a:off x="822960" y="2606039"/>
+            <a:ext cx="512064" cy="548640"/>
           </a:xfrm>
           <a:prstGeom prst="rect">
             <a:avLst/>
@@ -31578,7 +31684,7 @@
               <a:buNone/>
             </a:pPr>
             <a:r>
-              <a:rPr b="0" i="0" lang="en-US" sz="2000" u="none" cap="none" strike="noStrike">
+              <a:rPr b="0" i="0" lang="en-US" sz="1800" u="none" cap="none" strike="noStrike">
                 <a:solidFill>
                   <a:srgbClr val="E8EDF6"/>
                 </a:solidFill>
@@ -31595,14 +31701,14 @@
       </p:sp>
       <p:sp>
         <p:nvSpPr>
-          <p:cNvPr id="495" name="Google Shape;495;p18"/>
+          <p:cNvPr id="497" name="Google Shape;497;p18"/>
           <p:cNvSpPr txBox="1"/>
           <p:nvPr/>
         </p:nvSpPr>
         <p:spPr>
           <a:xfrm>
-            <a:off x="1508760" y="2834640"/>
-            <a:ext cx="2286000" cy="640080"/>
+            <a:off x="1463040" y="2606039"/>
+            <a:ext cx="2286000" cy="566928"/>
           </a:xfrm>
           <a:prstGeom prst="rect">
             <a:avLst/>
@@ -31631,7 +31737,7 @@
               <a:buNone/>
             </a:pPr>
             <a:r>
-              <a:rPr b="1" i="0" lang="en-US" sz="1550" u="none" cap="none" strike="noStrike">
+              <a:rPr b="1" i="0" lang="en-US" sz="1500" u="none" cap="none" strike="noStrike">
                 <a:solidFill>
                   <a:srgbClr val="818CF8"/>
                 </a:solidFill>
@@ -31648,14 +31754,14 @@
       </p:sp>
       <p:sp>
         <p:nvSpPr>
-          <p:cNvPr id="496" name="Google Shape;496;p18"/>
-          <p:cNvSpPr/>
-          <p:nvPr/>
-        </p:nvSpPr>
-        <p:spPr>
-          <a:xfrm>
-            <a:off x="3886200" y="2944368"/>
-            <a:ext cx="1766620" cy="420624"/>
+          <p:cNvPr id="498" name="Google Shape;498;p18"/>
+          <p:cNvSpPr/>
+          <p:nvPr/>
+        </p:nvSpPr>
+        <p:spPr>
+          <a:xfrm>
+            <a:off x="3840480" y="2679191"/>
+            <a:ext cx="1766620" cy="402336"/>
           </a:xfrm>
           <a:prstGeom prst="roundRect">
             <a:avLst>
@@ -31707,14 +31813,14 @@
       </p:sp>
       <p:sp>
         <p:nvSpPr>
-          <p:cNvPr id="497" name="Google Shape;497;p18"/>
+          <p:cNvPr id="499" name="Google Shape;499;p18"/>
           <p:cNvSpPr txBox="1"/>
           <p:nvPr/>
         </p:nvSpPr>
         <p:spPr>
           <a:xfrm>
-            <a:off x="3886200" y="2944368"/>
-            <a:ext cx="1766620" cy="420624"/>
+            <a:off x="3840480" y="2679191"/>
+            <a:ext cx="1766620" cy="402336"/>
           </a:xfrm>
           <a:prstGeom prst="rect">
             <a:avLst/>
@@ -31760,14 +31866,14 @@
       </p:sp>
       <p:sp>
         <p:nvSpPr>
-          <p:cNvPr id="498" name="Google Shape;498;p18"/>
-          <p:cNvSpPr/>
-          <p:nvPr/>
-        </p:nvSpPr>
-        <p:spPr>
-          <a:xfrm>
-            <a:off x="5817412" y="2944368"/>
-            <a:ext cx="1371600" cy="420624"/>
+          <p:cNvPr id="500" name="Google Shape;500;p18"/>
+          <p:cNvSpPr/>
+          <p:nvPr/>
+        </p:nvSpPr>
+        <p:spPr>
+          <a:xfrm>
+            <a:off x="5753404" y="2679191"/>
+            <a:ext cx="1371600" cy="402336"/>
           </a:xfrm>
           <a:prstGeom prst="roundRect">
             <a:avLst>
@@ -31819,14 +31925,14 @@
       </p:sp>
       <p:sp>
         <p:nvSpPr>
-          <p:cNvPr id="499" name="Google Shape;499;p18"/>
+          <p:cNvPr id="501" name="Google Shape;501;p18"/>
           <p:cNvSpPr txBox="1"/>
           <p:nvPr/>
         </p:nvSpPr>
         <p:spPr>
           <a:xfrm>
-            <a:off x="5817412" y="2944368"/>
-            <a:ext cx="1371600" cy="420624"/>
+            <a:off x="5753404" y="2679191"/>
+            <a:ext cx="1371600" cy="402336"/>
           </a:xfrm>
           <a:prstGeom prst="rect">
             <a:avLst/>
@@ -31872,14 +31978,14 @@
       </p:sp>
       <p:sp>
         <p:nvSpPr>
-          <p:cNvPr id="500" name="Google Shape;500;p18"/>
-          <p:cNvSpPr/>
-          <p:nvPr/>
-        </p:nvSpPr>
-        <p:spPr>
-          <a:xfrm>
-            <a:off x="7353604" y="2944368"/>
-            <a:ext cx="1964131" cy="420624"/>
+          <p:cNvPr id="502" name="Google Shape;502;p18"/>
+          <p:cNvSpPr/>
+          <p:nvPr/>
+        </p:nvSpPr>
+        <p:spPr>
+          <a:xfrm>
+            <a:off x="7271308" y="2679191"/>
+            <a:ext cx="1964131" cy="402336"/>
           </a:xfrm>
           <a:prstGeom prst="roundRect">
             <a:avLst>
@@ -31931,14 +32037,14 @@
       </p:sp>
       <p:sp>
         <p:nvSpPr>
-          <p:cNvPr id="501" name="Google Shape;501;p18"/>
+          <p:cNvPr id="503" name="Google Shape;503;p18"/>
           <p:cNvSpPr txBox="1"/>
           <p:nvPr/>
         </p:nvSpPr>
         <p:spPr>
           <a:xfrm>
-            <a:off x="7353604" y="2944368"/>
-            <a:ext cx="1964131" cy="420624"/>
+            <a:off x="7271308" y="2679191"/>
+            <a:ext cx="1964131" cy="402336"/>
           </a:xfrm>
           <a:prstGeom prst="rect">
             <a:avLst/>
@@ -31984,14 +32090,14 @@
       </p:sp>
       <p:sp>
         <p:nvSpPr>
-          <p:cNvPr id="502" name="Google Shape;502;p18"/>
-          <p:cNvSpPr/>
-          <p:nvPr/>
-        </p:nvSpPr>
-        <p:spPr>
-          <a:xfrm>
-            <a:off x="822960" y="3703320"/>
-            <a:ext cx="548640" cy="548640"/>
+          <p:cNvPr id="504" name="Google Shape;504;p18"/>
+          <p:cNvSpPr/>
+          <p:nvPr/>
+        </p:nvSpPr>
+        <p:spPr>
+          <a:xfrm>
+            <a:off x="822960" y="3364991"/>
+            <a:ext cx="512064" cy="512064"/>
           </a:xfrm>
           <a:prstGeom prst="ellipse">
             <a:avLst/>
@@ -32041,14 +32147,14 @@
       </p:sp>
       <p:sp>
         <p:nvSpPr>
-          <p:cNvPr id="503" name="Google Shape;503;p18"/>
+          <p:cNvPr id="505" name="Google Shape;505;p18"/>
           <p:cNvSpPr txBox="1"/>
           <p:nvPr/>
         </p:nvSpPr>
         <p:spPr>
           <a:xfrm>
-            <a:off x="822960" y="3675887"/>
-            <a:ext cx="548640" cy="566928"/>
+            <a:off x="822960" y="3337559"/>
+            <a:ext cx="512064" cy="548640"/>
           </a:xfrm>
           <a:prstGeom prst="rect">
             <a:avLst/>
@@ -32077,7 +32183,7 @@
               <a:buNone/>
             </a:pPr>
             <a:r>
-              <a:rPr b="0" i="0" lang="en-US" sz="2000" u="none" cap="none" strike="noStrike">
+              <a:rPr b="0" i="0" lang="en-US" sz="1800" u="none" cap="none" strike="noStrike">
                 <a:solidFill>
                   <a:srgbClr val="E8EDF6"/>
                 </a:solidFill>
@@ -32094,14 +32200,14 @@
       </p:sp>
       <p:sp>
         <p:nvSpPr>
-          <p:cNvPr id="504" name="Google Shape;504;p18"/>
+          <p:cNvPr id="506" name="Google Shape;506;p18"/>
           <p:cNvSpPr txBox="1"/>
           <p:nvPr/>
         </p:nvSpPr>
         <p:spPr>
           <a:xfrm>
-            <a:off x="1508760" y="3657600"/>
-            <a:ext cx="2286000" cy="640080"/>
+            <a:off x="1463040" y="3337559"/>
+            <a:ext cx="2286000" cy="566928"/>
           </a:xfrm>
           <a:prstGeom prst="rect">
             <a:avLst/>
@@ -32130,7 +32236,7 @@
               <a:buNone/>
             </a:pPr>
             <a:r>
-              <a:rPr b="1" i="0" lang="en-US" sz="1550" u="none" cap="none" strike="noStrike">
+              <a:rPr b="1" i="0" lang="en-US" sz="1500" u="none" cap="none" strike="noStrike">
                 <a:solidFill>
                   <a:srgbClr val="F5C32D"/>
                 </a:solidFill>
@@ -32147,14 +32253,14 @@
       </p:sp>
       <p:sp>
         <p:nvSpPr>
-          <p:cNvPr id="505" name="Google Shape;505;p18"/>
-          <p:cNvSpPr/>
-          <p:nvPr/>
-        </p:nvSpPr>
-        <p:spPr>
-          <a:xfrm>
-            <a:off x="3886200" y="3767328"/>
-            <a:ext cx="1569110" cy="420624"/>
+          <p:cNvPr id="507" name="Google Shape;507;p18"/>
+          <p:cNvSpPr/>
+          <p:nvPr/>
+        </p:nvSpPr>
+        <p:spPr>
+          <a:xfrm>
+            <a:off x="3840480" y="3410711"/>
+            <a:ext cx="1569110" cy="402336"/>
           </a:xfrm>
           <a:prstGeom prst="roundRect">
             <a:avLst>
@@ -32206,14 +32312,14 @@
       </p:sp>
       <p:sp>
         <p:nvSpPr>
-          <p:cNvPr id="506" name="Google Shape;506;p18"/>
+          <p:cNvPr id="508" name="Google Shape;508;p18"/>
           <p:cNvSpPr txBox="1"/>
           <p:nvPr/>
         </p:nvSpPr>
         <p:spPr>
           <a:xfrm>
-            <a:off x="3886200" y="3767328"/>
-            <a:ext cx="1569110" cy="420624"/>
+            <a:off x="3840480" y="3410711"/>
+            <a:ext cx="1569110" cy="402336"/>
           </a:xfrm>
           <a:prstGeom prst="rect">
             <a:avLst/>
@@ -32259,14 +32365,14 @@
       </p:sp>
       <p:sp>
         <p:nvSpPr>
-          <p:cNvPr id="507" name="Google Shape;507;p18"/>
-          <p:cNvSpPr/>
-          <p:nvPr/>
-        </p:nvSpPr>
-        <p:spPr>
-          <a:xfrm>
-            <a:off x="5619902" y="3767328"/>
-            <a:ext cx="1272844" cy="420624"/>
+          <p:cNvPr id="509" name="Google Shape;509;p18"/>
+          <p:cNvSpPr/>
+          <p:nvPr/>
+        </p:nvSpPr>
+        <p:spPr>
+          <a:xfrm>
+            <a:off x="5555894" y="3410711"/>
+            <a:ext cx="1272844" cy="402336"/>
           </a:xfrm>
           <a:prstGeom prst="roundRect">
             <a:avLst>
@@ -32318,14 +32424,14 @@
       </p:sp>
       <p:sp>
         <p:nvSpPr>
-          <p:cNvPr id="508" name="Google Shape;508;p18"/>
+          <p:cNvPr id="510" name="Google Shape;510;p18"/>
           <p:cNvSpPr txBox="1"/>
           <p:nvPr/>
         </p:nvSpPr>
         <p:spPr>
           <a:xfrm>
-            <a:off x="5619902" y="3767328"/>
-            <a:ext cx="1272844" cy="420624"/>
+            <a:off x="5555894" y="3410711"/>
+            <a:ext cx="1272844" cy="402336"/>
           </a:xfrm>
           <a:prstGeom prst="rect">
             <a:avLst/>
@@ -32371,14 +32477,14 @@
       </p:sp>
       <p:sp>
         <p:nvSpPr>
-          <p:cNvPr id="509" name="Google Shape;509;p18"/>
-          <p:cNvSpPr/>
-          <p:nvPr/>
-        </p:nvSpPr>
-        <p:spPr>
-          <a:xfrm>
-            <a:off x="7057339" y="3767328"/>
-            <a:ext cx="877824" cy="420624"/>
+          <p:cNvPr id="511" name="Google Shape;511;p18"/>
+          <p:cNvSpPr/>
+          <p:nvPr/>
+        </p:nvSpPr>
+        <p:spPr>
+          <a:xfrm>
+            <a:off x="6975043" y="3410711"/>
+            <a:ext cx="877824" cy="402336"/>
           </a:xfrm>
           <a:prstGeom prst="roundRect">
             <a:avLst>
@@ -32430,14 +32536,14 @@
       </p:sp>
       <p:sp>
         <p:nvSpPr>
-          <p:cNvPr id="510" name="Google Shape;510;p18"/>
+          <p:cNvPr id="512" name="Google Shape;512;p18"/>
           <p:cNvSpPr txBox="1"/>
           <p:nvPr/>
         </p:nvSpPr>
         <p:spPr>
           <a:xfrm>
-            <a:off x="7057339" y="3767328"/>
-            <a:ext cx="877824" cy="420624"/>
+            <a:off x="6975043" y="3410711"/>
+            <a:ext cx="877824" cy="402336"/>
           </a:xfrm>
           <a:prstGeom prst="rect">
             <a:avLst/>
@@ -32483,14 +32589,14 @@
       </p:sp>
       <p:sp>
         <p:nvSpPr>
-          <p:cNvPr id="511" name="Google Shape;511;p18"/>
-          <p:cNvSpPr/>
-          <p:nvPr/>
-        </p:nvSpPr>
-        <p:spPr>
-          <a:xfrm>
-            <a:off x="8099755" y="3767328"/>
-            <a:ext cx="1470355" cy="420624"/>
+          <p:cNvPr id="513" name="Google Shape;513;p18"/>
+          <p:cNvSpPr/>
+          <p:nvPr/>
+        </p:nvSpPr>
+        <p:spPr>
+          <a:xfrm>
+            <a:off x="7999171" y="3410711"/>
+            <a:ext cx="1470355" cy="402336"/>
           </a:xfrm>
           <a:prstGeom prst="roundRect">
             <a:avLst>
@@ -32542,14 +32648,14 @@
       </p:sp>
       <p:sp>
         <p:nvSpPr>
-          <p:cNvPr id="512" name="Google Shape;512;p18"/>
+          <p:cNvPr id="514" name="Google Shape;514;p18"/>
           <p:cNvSpPr txBox="1"/>
           <p:nvPr/>
         </p:nvSpPr>
         <p:spPr>
           <a:xfrm>
-            <a:off x="8099755" y="3767328"/>
-            <a:ext cx="1470355" cy="420624"/>
+            <a:off x="7999171" y="3410711"/>
+            <a:ext cx="1470355" cy="402336"/>
           </a:xfrm>
           <a:prstGeom prst="rect">
             <a:avLst/>
@@ -32595,14 +32701,625 @@
       </p:sp>
       <p:sp>
         <p:nvSpPr>
-          <p:cNvPr id="513" name="Google Shape;513;p18"/>
-          <p:cNvSpPr/>
-          <p:nvPr/>
-        </p:nvSpPr>
-        <p:spPr>
-          <a:xfrm>
-            <a:off x="822960" y="4526280"/>
-            <a:ext cx="548640" cy="548640"/>
+          <p:cNvPr id="515" name="Google Shape;515;p18"/>
+          <p:cNvSpPr/>
+          <p:nvPr/>
+        </p:nvSpPr>
+        <p:spPr>
+          <a:xfrm>
+            <a:off x="822960" y="4096511"/>
+            <a:ext cx="512064" cy="512064"/>
+          </a:xfrm>
+          <a:prstGeom prst="ellipse">
+            <a:avLst/>
+          </a:prstGeom>
+          <a:solidFill>
+            <a:srgbClr val="0F1626"/>
+          </a:solidFill>
+          <a:ln cap="flat" cmpd="sng" w="22850">
+            <a:solidFill>
+              <a:srgbClr val="C084FC"/>
+            </a:solidFill>
+            <a:prstDash val="solid"/>
+            <a:round/>
+            <a:headEnd len="sm" w="sm" type="none"/>
+            <a:tailEnd len="sm" w="sm" type="none"/>
+          </a:ln>
+        </p:spPr>
+        <p:txBody>
+          <a:bodyPr anchorCtr="0" anchor="ctr" bIns="45700" lIns="91425" spcFirstLastPara="1" rIns="91425" wrap="square" tIns="45700">
+            <a:noAutofit/>
+          </a:bodyPr>
+          <a:lstStyle/>
+          <a:p>
+            <a:pPr indent="0" lvl="0" marL="0" marR="0" rtl="0" algn="ctr">
+              <a:spcBef>
+                <a:spcPts val="0"/>
+              </a:spcBef>
+              <a:spcAft>
+                <a:spcPts val="0"/>
+              </a:spcAft>
+              <a:buNone/>
+            </a:pPr>
+            <a:r>
+              <a:t/>
+            </a:r>
+            <a:endParaRPr b="0" i="0" sz="1800" u="none" cap="none" strike="noStrike">
+              <a:solidFill>
+                <a:schemeClr val="dk1"/>
+              </a:solidFill>
+              <a:latin typeface="Calibri"/>
+              <a:ea typeface="Calibri"/>
+              <a:cs typeface="Calibri"/>
+              <a:sym typeface="Calibri"/>
+            </a:endParaRPr>
+          </a:p>
+        </p:txBody>
+      </p:sp>
+      <p:sp>
+        <p:nvSpPr>
+          <p:cNvPr id="516" name="Google Shape;516;p18"/>
+          <p:cNvSpPr txBox="1"/>
+          <p:nvPr/>
+        </p:nvSpPr>
+        <p:spPr>
+          <a:xfrm>
+            <a:off x="822960" y="4069079"/>
+            <a:ext cx="512064" cy="548640"/>
+          </a:xfrm>
+          <a:prstGeom prst="rect">
+            <a:avLst/>
+          </a:prstGeom>
+          <a:noFill/>
+          <a:ln>
+            <a:noFill/>
+          </a:ln>
+        </p:spPr>
+        <p:txBody>
+          <a:bodyPr anchorCtr="0" anchor="ctr" bIns="45700" lIns="91425" spcFirstLastPara="1" rIns="91425" wrap="square" tIns="45700">
+            <a:spAutoFit/>
+          </a:bodyPr>
+          <a:lstStyle/>
+          <a:p>
+            <a:pPr indent="0" lvl="0" marL="0" marR="0" rtl="0" algn="ctr">
+              <a:lnSpc>
+                <a:spcPct val="100000"/>
+              </a:lnSpc>
+              <a:spcBef>
+                <a:spcPts val="0"/>
+              </a:spcBef>
+              <a:spcAft>
+                <a:spcPts val="0"/>
+              </a:spcAft>
+              <a:buNone/>
+            </a:pPr>
+            <a:r>
+              <a:rPr b="0" i="0" lang="en-US" sz="1800" u="none" cap="none" strike="noStrike">
+                <a:solidFill>
+                  <a:srgbClr val="E8EDF6"/>
+                </a:solidFill>
+                <a:latin typeface="Quattrocento Sans"/>
+                <a:ea typeface="Quattrocento Sans"/>
+                <a:cs typeface="Quattrocento Sans"/>
+                <a:sym typeface="Quattrocento Sans"/>
+              </a:rPr>
+              <a:t>🤖</a:t>
+            </a:r>
+            <a:endParaRPr/>
+          </a:p>
+        </p:txBody>
+      </p:sp>
+      <p:sp>
+        <p:nvSpPr>
+          <p:cNvPr id="517" name="Google Shape;517;p18"/>
+          <p:cNvSpPr txBox="1"/>
+          <p:nvPr/>
+        </p:nvSpPr>
+        <p:spPr>
+          <a:xfrm>
+            <a:off x="1463040" y="4069079"/>
+            <a:ext cx="2286000" cy="566928"/>
+          </a:xfrm>
+          <a:prstGeom prst="rect">
+            <a:avLst/>
+          </a:prstGeom>
+          <a:noFill/>
+          <a:ln>
+            <a:noFill/>
+          </a:ln>
+        </p:spPr>
+        <p:txBody>
+          <a:bodyPr anchorCtr="0" anchor="ctr" bIns="45700" lIns="91425" spcFirstLastPara="1" rIns="91425" wrap="square" tIns="45700">
+            <a:spAutoFit/>
+          </a:bodyPr>
+          <a:lstStyle/>
+          <a:p>
+            <a:pPr indent="0" lvl="0" marL="0" marR="0" rtl="0" algn="l">
+              <a:lnSpc>
+                <a:spcPct val="100000"/>
+              </a:lnSpc>
+              <a:spcBef>
+                <a:spcPts val="0"/>
+              </a:spcBef>
+              <a:spcAft>
+                <a:spcPts val="0"/>
+              </a:spcAft>
+              <a:buNone/>
+            </a:pPr>
+            <a:r>
+              <a:rPr b="1" i="0" lang="en-US" sz="1500" u="none" cap="none" strike="noStrike">
+                <a:solidFill>
+                  <a:srgbClr val="C084FC"/>
+                </a:solidFill>
+                <a:latin typeface="Quattrocento Sans"/>
+                <a:ea typeface="Quattrocento Sans"/>
+                <a:cs typeface="Quattrocento Sans"/>
+                <a:sym typeface="Quattrocento Sans"/>
+              </a:rPr>
+              <a:t>AI assistant</a:t>
+            </a:r>
+            <a:endParaRPr/>
+          </a:p>
+        </p:txBody>
+      </p:sp>
+      <p:sp>
+        <p:nvSpPr>
+          <p:cNvPr id="518" name="Google Shape;518;p18"/>
+          <p:cNvSpPr/>
+          <p:nvPr/>
+        </p:nvSpPr>
+        <p:spPr>
+          <a:xfrm>
+            <a:off x="3840480" y="4142231"/>
+            <a:ext cx="1174089" cy="402336"/>
+          </a:xfrm>
+          <a:prstGeom prst="roundRect">
+            <a:avLst>
+              <a:gd fmla="val 16667" name="adj"/>
+            </a:avLst>
+          </a:prstGeom>
+          <a:solidFill>
+            <a:srgbClr val="141C2B"/>
+          </a:solidFill>
+          <a:ln cap="flat" cmpd="sng" w="12700">
+            <a:solidFill>
+              <a:srgbClr val="2A3550"/>
+            </a:solidFill>
+            <a:prstDash val="solid"/>
+            <a:round/>
+            <a:headEnd len="sm" w="sm" type="none"/>
+            <a:tailEnd len="sm" w="sm" type="none"/>
+          </a:ln>
+        </p:spPr>
+        <p:txBody>
+          <a:bodyPr anchorCtr="0" anchor="ctr" bIns="45700" lIns="91425" spcFirstLastPara="1" rIns="91425" wrap="square" tIns="45700">
+            <a:noAutofit/>
+          </a:bodyPr>
+          <a:lstStyle/>
+          <a:p>
+            <a:pPr indent="0" lvl="0" marL="0" marR="0" rtl="0" algn="ctr">
+              <a:spcBef>
+                <a:spcPts val="0"/>
+              </a:spcBef>
+              <a:spcAft>
+                <a:spcPts val="0"/>
+              </a:spcAft>
+              <a:buNone/>
+            </a:pPr>
+            <a:r>
+              <a:t/>
+            </a:r>
+            <a:endParaRPr b="0" i="0" sz="1800" u="none" cap="none" strike="noStrike">
+              <a:solidFill>
+                <a:schemeClr val="dk1"/>
+              </a:solidFill>
+              <a:latin typeface="Calibri"/>
+              <a:ea typeface="Calibri"/>
+              <a:cs typeface="Calibri"/>
+              <a:sym typeface="Calibri"/>
+            </a:endParaRPr>
+          </a:p>
+        </p:txBody>
+      </p:sp>
+      <p:sp>
+        <p:nvSpPr>
+          <p:cNvPr id="519" name="Google Shape;519;p18"/>
+          <p:cNvSpPr txBox="1"/>
+          <p:nvPr/>
+        </p:nvSpPr>
+        <p:spPr>
+          <a:xfrm>
+            <a:off x="3840480" y="4142231"/>
+            <a:ext cx="1174089" cy="402336"/>
+          </a:xfrm>
+          <a:prstGeom prst="rect">
+            <a:avLst/>
+          </a:prstGeom>
+          <a:noFill/>
+          <a:ln>
+            <a:noFill/>
+          </a:ln>
+        </p:spPr>
+        <p:txBody>
+          <a:bodyPr anchorCtr="0" anchor="ctr" bIns="45700" lIns="91425" spcFirstLastPara="1" rIns="91425" wrap="square" tIns="45700">
+            <a:spAutoFit/>
+          </a:bodyPr>
+          <a:lstStyle/>
+          <a:p>
+            <a:pPr indent="0" lvl="0" marL="0" marR="0" rtl="0" algn="ctr">
+              <a:lnSpc>
+                <a:spcPct val="100000"/>
+              </a:lnSpc>
+              <a:spcBef>
+                <a:spcPts val="0"/>
+              </a:spcBef>
+              <a:spcAft>
+                <a:spcPts val="0"/>
+              </a:spcAft>
+              <a:buNone/>
+            </a:pPr>
+            <a:r>
+              <a:rPr b="0" i="0" lang="en-US" sz="1250" u="none" cap="none" strike="noStrike">
+                <a:solidFill>
+                  <a:srgbClr val="E8EDF6"/>
+                </a:solidFill>
+                <a:latin typeface="Quattrocento Sans"/>
+                <a:ea typeface="Quattrocento Sans"/>
+                <a:cs typeface="Quattrocento Sans"/>
+                <a:sym typeface="Quattrocento Sans"/>
+              </a:rPr>
+              <a:t>🦙 Ollama</a:t>
+            </a:r>
+            <a:endParaRPr/>
+          </a:p>
+        </p:txBody>
+      </p:sp>
+      <p:sp>
+        <p:nvSpPr>
+          <p:cNvPr id="520" name="Google Shape;520;p18"/>
+          <p:cNvSpPr/>
+          <p:nvPr/>
+        </p:nvSpPr>
+        <p:spPr>
+          <a:xfrm>
+            <a:off x="5160873" y="4142231"/>
+            <a:ext cx="1371600" cy="402336"/>
+          </a:xfrm>
+          <a:prstGeom prst="roundRect">
+            <a:avLst>
+              <a:gd fmla="val 16667" name="adj"/>
+            </a:avLst>
+          </a:prstGeom>
+          <a:solidFill>
+            <a:srgbClr val="141C2B"/>
+          </a:solidFill>
+          <a:ln cap="flat" cmpd="sng" w="12700">
+            <a:solidFill>
+              <a:srgbClr val="2A3550"/>
+            </a:solidFill>
+            <a:prstDash val="solid"/>
+            <a:round/>
+            <a:headEnd len="sm" w="sm" type="none"/>
+            <a:tailEnd len="sm" w="sm" type="none"/>
+          </a:ln>
+        </p:spPr>
+        <p:txBody>
+          <a:bodyPr anchorCtr="0" anchor="ctr" bIns="45700" lIns="91425" spcFirstLastPara="1" rIns="91425" wrap="square" tIns="45700">
+            <a:noAutofit/>
+          </a:bodyPr>
+          <a:lstStyle/>
+          <a:p>
+            <a:pPr indent="0" lvl="0" marL="0" marR="0" rtl="0" algn="ctr">
+              <a:spcBef>
+                <a:spcPts val="0"/>
+              </a:spcBef>
+              <a:spcAft>
+                <a:spcPts val="0"/>
+              </a:spcAft>
+              <a:buNone/>
+            </a:pPr>
+            <a:r>
+              <a:t/>
+            </a:r>
+            <a:endParaRPr b="0" i="0" sz="1800" u="none" cap="none" strike="noStrike">
+              <a:solidFill>
+                <a:schemeClr val="dk1"/>
+              </a:solidFill>
+              <a:latin typeface="Calibri"/>
+              <a:ea typeface="Calibri"/>
+              <a:cs typeface="Calibri"/>
+              <a:sym typeface="Calibri"/>
+            </a:endParaRPr>
+          </a:p>
+        </p:txBody>
+      </p:sp>
+      <p:sp>
+        <p:nvSpPr>
+          <p:cNvPr id="521" name="Google Shape;521;p18"/>
+          <p:cNvSpPr txBox="1"/>
+          <p:nvPr/>
+        </p:nvSpPr>
+        <p:spPr>
+          <a:xfrm>
+            <a:off x="5160873" y="4142231"/>
+            <a:ext cx="1371600" cy="402336"/>
+          </a:xfrm>
+          <a:prstGeom prst="rect">
+            <a:avLst/>
+          </a:prstGeom>
+          <a:noFill/>
+          <a:ln>
+            <a:noFill/>
+          </a:ln>
+        </p:spPr>
+        <p:txBody>
+          <a:bodyPr anchorCtr="0" anchor="ctr" bIns="45700" lIns="91425" spcFirstLastPara="1" rIns="91425" wrap="square" tIns="45700">
+            <a:spAutoFit/>
+          </a:bodyPr>
+          <a:lstStyle/>
+          <a:p>
+            <a:pPr indent="0" lvl="0" marL="0" marR="0" rtl="0" algn="ctr">
+              <a:lnSpc>
+                <a:spcPct val="100000"/>
+              </a:lnSpc>
+              <a:spcBef>
+                <a:spcPts val="0"/>
+              </a:spcBef>
+              <a:spcAft>
+                <a:spcPts val="0"/>
+              </a:spcAft>
+              <a:buNone/>
+            </a:pPr>
+            <a:r>
+              <a:rPr b="0" i="0" lang="en-US" sz="1250" u="none" cap="none" strike="noStrike">
+                <a:solidFill>
+                  <a:srgbClr val="E8EDF6"/>
+                </a:solidFill>
+                <a:latin typeface="Quattrocento Sans"/>
+                <a:ea typeface="Quattrocento Sans"/>
+                <a:cs typeface="Quattrocento Sans"/>
+                <a:sym typeface="Quattrocento Sans"/>
+              </a:rPr>
+              <a:t>💬 llama3.2</a:t>
+            </a:r>
+            <a:endParaRPr/>
+          </a:p>
+        </p:txBody>
+      </p:sp>
+      <p:sp>
+        <p:nvSpPr>
+          <p:cNvPr id="522" name="Google Shape;522;p18"/>
+          <p:cNvSpPr/>
+          <p:nvPr/>
+        </p:nvSpPr>
+        <p:spPr>
+          <a:xfrm>
+            <a:off x="6678777" y="4142231"/>
+            <a:ext cx="1470355" cy="402336"/>
+          </a:xfrm>
+          <a:prstGeom prst="roundRect">
+            <a:avLst>
+              <a:gd fmla="val 16667" name="adj"/>
+            </a:avLst>
+          </a:prstGeom>
+          <a:solidFill>
+            <a:srgbClr val="141C2B"/>
+          </a:solidFill>
+          <a:ln cap="flat" cmpd="sng" w="12700">
+            <a:solidFill>
+              <a:srgbClr val="2A3550"/>
+            </a:solidFill>
+            <a:prstDash val="solid"/>
+            <a:round/>
+            <a:headEnd len="sm" w="sm" type="none"/>
+            <a:tailEnd len="sm" w="sm" type="none"/>
+          </a:ln>
+        </p:spPr>
+        <p:txBody>
+          <a:bodyPr anchorCtr="0" anchor="ctr" bIns="45700" lIns="91425" spcFirstLastPara="1" rIns="91425" wrap="square" tIns="45700">
+            <a:noAutofit/>
+          </a:bodyPr>
+          <a:lstStyle/>
+          <a:p>
+            <a:pPr indent="0" lvl="0" marL="0" marR="0" rtl="0" algn="ctr">
+              <a:spcBef>
+                <a:spcPts val="0"/>
+              </a:spcBef>
+              <a:spcAft>
+                <a:spcPts val="0"/>
+              </a:spcAft>
+              <a:buNone/>
+            </a:pPr>
+            <a:r>
+              <a:t/>
+            </a:r>
+            <a:endParaRPr b="0" i="0" sz="1800" u="none" cap="none" strike="noStrike">
+              <a:solidFill>
+                <a:schemeClr val="dk1"/>
+              </a:solidFill>
+              <a:latin typeface="Calibri"/>
+              <a:ea typeface="Calibri"/>
+              <a:cs typeface="Calibri"/>
+              <a:sym typeface="Calibri"/>
+            </a:endParaRPr>
+          </a:p>
+        </p:txBody>
+      </p:sp>
+      <p:sp>
+        <p:nvSpPr>
+          <p:cNvPr id="523" name="Google Shape;523;p18"/>
+          <p:cNvSpPr txBox="1"/>
+          <p:nvPr/>
+        </p:nvSpPr>
+        <p:spPr>
+          <a:xfrm>
+            <a:off x="6678777" y="4142231"/>
+            <a:ext cx="1470355" cy="402336"/>
+          </a:xfrm>
+          <a:prstGeom prst="rect">
+            <a:avLst/>
+          </a:prstGeom>
+          <a:noFill/>
+          <a:ln>
+            <a:noFill/>
+          </a:ln>
+        </p:spPr>
+        <p:txBody>
+          <a:bodyPr anchorCtr="0" anchor="ctr" bIns="45700" lIns="91425" spcFirstLastPara="1" rIns="91425" wrap="square" tIns="45700">
+            <a:spAutoFit/>
+          </a:bodyPr>
+          <a:lstStyle/>
+          <a:p>
+            <a:pPr indent="0" lvl="0" marL="0" marR="0" rtl="0" algn="ctr">
+              <a:lnSpc>
+                <a:spcPct val="100000"/>
+              </a:lnSpc>
+              <a:spcBef>
+                <a:spcPts val="0"/>
+              </a:spcBef>
+              <a:spcAft>
+                <a:spcPts val="0"/>
+              </a:spcAft>
+              <a:buNone/>
+            </a:pPr>
+            <a:r>
+              <a:rPr b="0" i="0" lang="en-US" sz="1250" u="none" cap="none" strike="noStrike">
+                <a:solidFill>
+                  <a:srgbClr val="E8EDF6"/>
+                </a:solidFill>
+                <a:latin typeface="Quattrocento Sans"/>
+                <a:ea typeface="Quattrocento Sans"/>
+                <a:cs typeface="Quattrocento Sans"/>
+                <a:sym typeface="Quattrocento Sans"/>
+              </a:rPr>
+              <a:t>🧩 LangGraph</a:t>
+            </a:r>
+            <a:endParaRPr/>
+          </a:p>
+        </p:txBody>
+      </p:sp>
+      <p:sp>
+        <p:nvSpPr>
+          <p:cNvPr id="524" name="Google Shape;524;p18"/>
+          <p:cNvSpPr/>
+          <p:nvPr/>
+        </p:nvSpPr>
+        <p:spPr>
+          <a:xfrm>
+            <a:off x="8295436" y="4142231"/>
+            <a:ext cx="877824" cy="402336"/>
+          </a:xfrm>
+          <a:prstGeom prst="roundRect">
+            <a:avLst>
+              <a:gd fmla="val 16667" name="adj"/>
+            </a:avLst>
+          </a:prstGeom>
+          <a:solidFill>
+            <a:srgbClr val="141C2B"/>
+          </a:solidFill>
+          <a:ln cap="flat" cmpd="sng" w="12700">
+            <a:solidFill>
+              <a:srgbClr val="2A3550"/>
+            </a:solidFill>
+            <a:prstDash val="solid"/>
+            <a:round/>
+            <a:headEnd len="sm" w="sm" type="none"/>
+            <a:tailEnd len="sm" w="sm" type="none"/>
+          </a:ln>
+        </p:spPr>
+        <p:txBody>
+          <a:bodyPr anchorCtr="0" anchor="ctr" bIns="45700" lIns="91425" spcFirstLastPara="1" rIns="91425" wrap="square" tIns="45700">
+            <a:noAutofit/>
+          </a:bodyPr>
+          <a:lstStyle/>
+          <a:p>
+            <a:pPr indent="0" lvl="0" marL="0" marR="0" rtl="0" algn="ctr">
+              <a:spcBef>
+                <a:spcPts val="0"/>
+              </a:spcBef>
+              <a:spcAft>
+                <a:spcPts val="0"/>
+              </a:spcAft>
+              <a:buNone/>
+            </a:pPr>
+            <a:r>
+              <a:t/>
+            </a:r>
+            <a:endParaRPr b="0" i="0" sz="1800" u="none" cap="none" strike="noStrike">
+              <a:solidFill>
+                <a:schemeClr val="dk1"/>
+              </a:solidFill>
+              <a:latin typeface="Calibri"/>
+              <a:ea typeface="Calibri"/>
+              <a:cs typeface="Calibri"/>
+              <a:sym typeface="Calibri"/>
+            </a:endParaRPr>
+          </a:p>
+        </p:txBody>
+      </p:sp>
+      <p:sp>
+        <p:nvSpPr>
+          <p:cNvPr id="525" name="Google Shape;525;p18"/>
+          <p:cNvSpPr txBox="1"/>
+          <p:nvPr/>
+        </p:nvSpPr>
+        <p:spPr>
+          <a:xfrm>
+            <a:off x="8295436" y="4142231"/>
+            <a:ext cx="877824" cy="402336"/>
+          </a:xfrm>
+          <a:prstGeom prst="rect">
+            <a:avLst/>
+          </a:prstGeom>
+          <a:noFill/>
+          <a:ln>
+            <a:noFill/>
+          </a:ln>
+        </p:spPr>
+        <p:txBody>
+          <a:bodyPr anchorCtr="0" anchor="ctr" bIns="45700" lIns="91425" spcFirstLastPara="1" rIns="91425" wrap="square" tIns="45700">
+            <a:spAutoFit/>
+          </a:bodyPr>
+          <a:lstStyle/>
+          <a:p>
+            <a:pPr indent="0" lvl="0" marL="0" marR="0" rtl="0" algn="ctr">
+              <a:lnSpc>
+                <a:spcPct val="100000"/>
+              </a:lnSpc>
+              <a:spcBef>
+                <a:spcPts val="0"/>
+              </a:spcBef>
+              <a:spcAft>
+                <a:spcPts val="0"/>
+              </a:spcAft>
+              <a:buNone/>
+            </a:pPr>
+            <a:r>
+              <a:rPr b="0" i="0" lang="en-US" sz="1250" u="none" cap="none" strike="noStrike">
+                <a:solidFill>
+                  <a:srgbClr val="E8EDF6"/>
+                </a:solidFill>
+                <a:latin typeface="Quattrocento Sans"/>
+                <a:ea typeface="Quattrocento Sans"/>
+                <a:cs typeface="Quattrocento Sans"/>
+                <a:sym typeface="Quattrocento Sans"/>
+              </a:rPr>
+              <a:t>⚡ GPU</a:t>
+            </a:r>
+            <a:endParaRPr/>
+          </a:p>
+        </p:txBody>
+      </p:sp>
+      <p:sp>
+        <p:nvSpPr>
+          <p:cNvPr id="526" name="Google Shape;526;p18"/>
+          <p:cNvSpPr/>
+          <p:nvPr/>
+        </p:nvSpPr>
+        <p:spPr>
+          <a:xfrm>
+            <a:off x="822960" y="4828031"/>
+            <a:ext cx="512064" cy="512064"/>
           </a:xfrm>
           <a:prstGeom prst="ellipse">
             <a:avLst/>
@@ -32652,14 +33369,14 @@
       </p:sp>
       <p:sp>
         <p:nvSpPr>
-          <p:cNvPr id="514" name="Google Shape;514;p18"/>
+          <p:cNvPr id="527" name="Google Shape;527;p18"/>
           <p:cNvSpPr txBox="1"/>
           <p:nvPr/>
         </p:nvSpPr>
         <p:spPr>
           <a:xfrm>
-            <a:off x="822960" y="4498848"/>
-            <a:ext cx="548640" cy="566928"/>
+            <a:off x="822960" y="4800599"/>
+            <a:ext cx="512064" cy="548640"/>
           </a:xfrm>
           <a:prstGeom prst="rect">
             <a:avLst/>
@@ -32688,7 +33405,7 @@
               <a:buNone/>
             </a:pPr>
             <a:r>
-              <a:rPr b="0" i="0" lang="en-US" sz="2000" u="none" cap="none" strike="noStrike">
+              <a:rPr b="0" i="0" lang="en-US" sz="1800" u="none" cap="none" strike="noStrike">
                 <a:solidFill>
                   <a:srgbClr val="E8EDF6"/>
                 </a:solidFill>
@@ -32705,14 +33422,14 @@
       </p:sp>
       <p:sp>
         <p:nvSpPr>
-          <p:cNvPr id="515" name="Google Shape;515;p18"/>
+          <p:cNvPr id="528" name="Google Shape;528;p18"/>
           <p:cNvSpPr txBox="1"/>
           <p:nvPr/>
         </p:nvSpPr>
         <p:spPr>
           <a:xfrm>
-            <a:off x="1508760" y="4480560"/>
-            <a:ext cx="2286000" cy="640080"/>
+            <a:off x="1463040" y="4800599"/>
+            <a:ext cx="2286000" cy="566928"/>
           </a:xfrm>
           <a:prstGeom prst="rect">
             <a:avLst/>
@@ -32741,7 +33458,7 @@
               <a:buNone/>
             </a:pPr>
             <a:r>
-              <a:rPr b="1" i="0" lang="en-US" sz="1550" u="none" cap="none" strike="noStrike">
+              <a:rPr b="1" i="0" lang="en-US" sz="1500" u="none" cap="none" strike="noStrike">
                 <a:solidFill>
                   <a:srgbClr val="28E68C"/>
                 </a:solidFill>
@@ -32758,14 +33475,14 @@
       </p:sp>
       <p:sp>
         <p:nvSpPr>
-          <p:cNvPr id="516" name="Google Shape;516;p18"/>
-          <p:cNvSpPr/>
-          <p:nvPr/>
-        </p:nvSpPr>
-        <p:spPr>
-          <a:xfrm>
-            <a:off x="3886200" y="4590288"/>
-            <a:ext cx="1174089" cy="420624"/>
+          <p:cNvPr id="529" name="Google Shape;529;p18"/>
+          <p:cNvSpPr/>
+          <p:nvPr/>
+        </p:nvSpPr>
+        <p:spPr>
+          <a:xfrm>
+            <a:off x="3840480" y="4873751"/>
+            <a:ext cx="1174089" cy="402336"/>
           </a:xfrm>
           <a:prstGeom prst="roundRect">
             <a:avLst>
@@ -32817,14 +33534,14 @@
       </p:sp>
       <p:sp>
         <p:nvSpPr>
-          <p:cNvPr id="517" name="Google Shape;517;p18"/>
+          <p:cNvPr id="530" name="Google Shape;530;p18"/>
           <p:cNvSpPr txBox="1"/>
           <p:nvPr/>
         </p:nvSpPr>
         <p:spPr>
           <a:xfrm>
-            <a:off x="3886200" y="4590288"/>
-            <a:ext cx="1174089" cy="420624"/>
+            <a:off x="3840480" y="4873751"/>
+            <a:ext cx="1174089" cy="402336"/>
           </a:xfrm>
           <a:prstGeom prst="rect">
             <a:avLst/>
@@ -32870,14 +33587,14 @@
       </p:sp>
       <p:sp>
         <p:nvSpPr>
-          <p:cNvPr id="518" name="Google Shape;518;p18"/>
-          <p:cNvSpPr/>
-          <p:nvPr/>
-        </p:nvSpPr>
-        <p:spPr>
-          <a:xfrm>
-            <a:off x="5224881" y="4590288"/>
-            <a:ext cx="976579" cy="420624"/>
+          <p:cNvPr id="531" name="Google Shape;531;p18"/>
+          <p:cNvSpPr/>
+          <p:nvPr/>
+        </p:nvSpPr>
+        <p:spPr>
+          <a:xfrm>
+            <a:off x="5160873" y="4873751"/>
+            <a:ext cx="976579" cy="402336"/>
           </a:xfrm>
           <a:prstGeom prst="roundRect">
             <a:avLst>
@@ -32929,14 +33646,14 @@
       </p:sp>
       <p:sp>
         <p:nvSpPr>
-          <p:cNvPr id="519" name="Google Shape;519;p18"/>
+          <p:cNvPr id="532" name="Google Shape;532;p18"/>
           <p:cNvSpPr txBox="1"/>
           <p:nvPr/>
         </p:nvSpPr>
         <p:spPr>
           <a:xfrm>
-            <a:off x="5224881" y="4590288"/>
-            <a:ext cx="976579" cy="420624"/>
+            <a:off x="5160873" y="4873751"/>
+            <a:ext cx="976579" cy="402336"/>
           </a:xfrm>
           <a:prstGeom prst="rect">
             <a:avLst/>
@@ -32982,14 +33699,14 @@
       </p:sp>
       <p:sp>
         <p:nvSpPr>
-          <p:cNvPr id="520" name="Google Shape;520;p18"/>
-          <p:cNvSpPr/>
-          <p:nvPr/>
-        </p:nvSpPr>
-        <p:spPr>
-          <a:xfrm>
-            <a:off x="6366052" y="4590288"/>
-            <a:ext cx="1667865" cy="420624"/>
+          <p:cNvPr id="533" name="Google Shape;533;p18"/>
+          <p:cNvSpPr/>
+          <p:nvPr/>
+        </p:nvSpPr>
+        <p:spPr>
+          <a:xfrm>
+            <a:off x="6283756" y="4873751"/>
+            <a:ext cx="1667865" cy="402336"/>
           </a:xfrm>
           <a:prstGeom prst="roundRect">
             <a:avLst>
@@ -33041,14 +33758,14 @@
       </p:sp>
       <p:sp>
         <p:nvSpPr>
-          <p:cNvPr id="521" name="Google Shape;521;p18"/>
+          <p:cNvPr id="534" name="Google Shape;534;p18"/>
           <p:cNvSpPr txBox="1"/>
           <p:nvPr/>
         </p:nvSpPr>
         <p:spPr>
           <a:xfrm>
-            <a:off x="6366052" y="4590288"/>
-            <a:ext cx="1667865" cy="420624"/>
+            <a:off x="6283756" y="4873751"/>
+            <a:ext cx="1667865" cy="402336"/>
           </a:xfrm>
           <a:prstGeom prst="rect">
             <a:avLst/>
@@ -33094,14 +33811,14 @@
       </p:sp>
       <p:sp>
         <p:nvSpPr>
-          <p:cNvPr id="522" name="Google Shape;522;p18"/>
-          <p:cNvSpPr/>
-          <p:nvPr/>
-        </p:nvSpPr>
-        <p:spPr>
-          <a:xfrm>
-            <a:off x="822960" y="5349240"/>
-            <a:ext cx="548640" cy="548640"/>
+          <p:cNvPr id="535" name="Google Shape;535;p18"/>
+          <p:cNvSpPr/>
+          <p:nvPr/>
+        </p:nvSpPr>
+        <p:spPr>
+          <a:xfrm>
+            <a:off x="822960" y="5559551"/>
+            <a:ext cx="512064" cy="512064"/>
           </a:xfrm>
           <a:prstGeom prst="ellipse">
             <a:avLst/>
@@ -33151,14 +33868,14 @@
       </p:sp>
       <p:sp>
         <p:nvSpPr>
-          <p:cNvPr id="523" name="Google Shape;523;p18"/>
+          <p:cNvPr id="536" name="Google Shape;536;p18"/>
           <p:cNvSpPr txBox="1"/>
           <p:nvPr/>
         </p:nvSpPr>
         <p:spPr>
           <a:xfrm>
-            <a:off x="822960" y="5321808"/>
-            <a:ext cx="548640" cy="566928"/>
+            <a:off x="822960" y="5532119"/>
+            <a:ext cx="512064" cy="548640"/>
           </a:xfrm>
           <a:prstGeom prst="rect">
             <a:avLst/>
@@ -33187,7 +33904,7 @@
               <a:buNone/>
             </a:pPr>
             <a:r>
-              <a:rPr b="0" i="0" lang="en-US" sz="2000" u="none" cap="none" strike="noStrike">
+              <a:rPr b="0" i="0" lang="en-US" sz="1800" u="none" cap="none" strike="noStrike">
                 <a:solidFill>
                   <a:srgbClr val="E8EDF6"/>
                 </a:solidFill>
@@ -33204,14 +33921,14 @@
       </p:sp>
       <p:sp>
         <p:nvSpPr>
-          <p:cNvPr id="524" name="Google Shape;524;p18"/>
+          <p:cNvPr id="537" name="Google Shape;537;p18"/>
           <p:cNvSpPr txBox="1"/>
           <p:nvPr/>
         </p:nvSpPr>
         <p:spPr>
           <a:xfrm>
-            <a:off x="1508760" y="5303520"/>
-            <a:ext cx="2286000" cy="640080"/>
+            <a:off x="1463040" y="5532119"/>
+            <a:ext cx="2286000" cy="566928"/>
           </a:xfrm>
           <a:prstGeom prst="rect">
             <a:avLst/>
@@ -33240,7 +33957,7 @@
               <a:buNone/>
             </a:pPr>
             <a:r>
-              <a:rPr b="1" i="0" lang="en-US" sz="1550" u="none" cap="none" strike="noStrike">
+              <a:rPr b="1" i="0" lang="en-US" sz="1500" u="none" cap="none" strike="noStrike">
                 <a:solidFill>
                   <a:srgbClr val="5EEAD4"/>
                 </a:solidFill>
@@ -33257,14 +33974,14 @@
       </p:sp>
       <p:sp>
         <p:nvSpPr>
-          <p:cNvPr id="525" name="Google Shape;525;p18"/>
-          <p:cNvSpPr/>
-          <p:nvPr/>
-        </p:nvSpPr>
-        <p:spPr>
-          <a:xfrm>
-            <a:off x="3886200" y="5413248"/>
-            <a:ext cx="1174089" cy="420624"/>
+          <p:cNvPr id="538" name="Google Shape;538;p18"/>
+          <p:cNvSpPr/>
+          <p:nvPr/>
+        </p:nvSpPr>
+        <p:spPr>
+          <a:xfrm>
+            <a:off x="3840480" y="5605271"/>
+            <a:ext cx="1174089" cy="402336"/>
           </a:xfrm>
           <a:prstGeom prst="roundRect">
             <a:avLst>
@@ -33316,14 +34033,14 @@
       </p:sp>
       <p:sp>
         <p:nvSpPr>
-          <p:cNvPr id="526" name="Google Shape;526;p18"/>
+          <p:cNvPr id="539" name="Google Shape;539;p18"/>
           <p:cNvSpPr txBox="1"/>
           <p:nvPr/>
         </p:nvSpPr>
         <p:spPr>
           <a:xfrm>
-            <a:off x="3886200" y="5413248"/>
-            <a:ext cx="1174089" cy="420624"/>
+            <a:off x="3840480" y="5605271"/>
+            <a:ext cx="1174089" cy="402336"/>
           </a:xfrm>
           <a:prstGeom prst="rect">
             <a:avLst/>
@@ -33369,14 +34086,14 @@
       </p:sp>
       <p:sp>
         <p:nvSpPr>
-          <p:cNvPr id="527" name="Google Shape;527;p18"/>
-          <p:cNvSpPr/>
-          <p:nvPr/>
-        </p:nvSpPr>
-        <p:spPr>
-          <a:xfrm>
-            <a:off x="5224881" y="5413248"/>
-            <a:ext cx="1075334" cy="420624"/>
+          <p:cNvPr id="540" name="Google Shape;540;p18"/>
+          <p:cNvSpPr/>
+          <p:nvPr/>
+        </p:nvSpPr>
+        <p:spPr>
+          <a:xfrm>
+            <a:off x="5160873" y="5605271"/>
+            <a:ext cx="1075334" cy="402336"/>
           </a:xfrm>
           <a:prstGeom prst="roundRect">
             <a:avLst>
@@ -33428,14 +34145,14 @@
       </p:sp>
       <p:sp>
         <p:nvSpPr>
-          <p:cNvPr id="528" name="Google Shape;528;p18"/>
+          <p:cNvPr id="541" name="Google Shape;541;p18"/>
           <p:cNvSpPr txBox="1"/>
           <p:nvPr/>
         </p:nvSpPr>
         <p:spPr>
           <a:xfrm>
-            <a:off x="5224881" y="5413248"/>
-            <a:ext cx="1075334" cy="420624"/>
+            <a:off x="5160873" y="5605271"/>
+            <a:ext cx="1075334" cy="402336"/>
           </a:xfrm>
           <a:prstGeom prst="rect">
             <a:avLst/>
@@ -33481,14 +34198,14 @@
       </p:sp>
       <p:sp>
         <p:nvSpPr>
-          <p:cNvPr id="529" name="Google Shape;529;p18"/>
-          <p:cNvSpPr/>
-          <p:nvPr/>
-        </p:nvSpPr>
-        <p:spPr>
-          <a:xfrm>
-            <a:off x="6464808" y="5413248"/>
-            <a:ext cx="1272844" cy="420624"/>
+          <p:cNvPr id="542" name="Google Shape;542;p18"/>
+          <p:cNvSpPr/>
+          <p:nvPr/>
+        </p:nvSpPr>
+        <p:spPr>
+          <a:xfrm>
+            <a:off x="6382512" y="5605271"/>
+            <a:ext cx="1272844" cy="402336"/>
           </a:xfrm>
           <a:prstGeom prst="roundRect">
             <a:avLst>
@@ -33540,14 +34257,14 @@
       </p:sp>
       <p:sp>
         <p:nvSpPr>
-          <p:cNvPr id="530" name="Google Shape;530;p18"/>
+          <p:cNvPr id="543" name="Google Shape;543;p18"/>
           <p:cNvSpPr txBox="1"/>
           <p:nvPr/>
         </p:nvSpPr>
         <p:spPr>
           <a:xfrm>
-            <a:off x="6464808" y="5413248"/>
-            <a:ext cx="1272844" cy="420624"/>
+            <a:off x="6382512" y="5605271"/>
+            <a:ext cx="1272844" cy="402336"/>
           </a:xfrm>
           <a:prstGeom prst="rect">
             <a:avLst/>
@@ -33593,7 +34310,7 @@
       </p:sp>
       <p:pic>
         <p:nvPicPr>
-          <p:cNvPr descr="garaza_logo.png" id="531" name="Google Shape;531;p18"/>
+          <p:cNvPr descr="garaza_logo.png" id="544" name="Google Shape;544;p18"/>
           <p:cNvPicPr preferRelativeResize="0"/>
           <p:nvPr/>
         </p:nvPicPr>
@@ -33620,7 +34337,7 @@
       </p:pic>
       <p:sp>
         <p:nvSpPr>
-          <p:cNvPr id="532" name="Google Shape;532;p18"/>
+          <p:cNvPr id="545" name="Google Shape;545;p18"/>
           <p:cNvSpPr txBox="1"/>
           <p:nvPr/>
         </p:nvSpPr>
@@ -33696,7 +34413,7 @@
   <p:cSld>
     <p:spTree>
       <p:nvGrpSpPr>
-        <p:cNvPr id="536" name="Shape 536"/>
+        <p:cNvPr id="549" name="Shape 549"/>
         <p:cNvGrpSpPr/>
         <p:nvPr/>
       </p:nvGrpSpPr>
@@ -33710,7 +34427,7 @@
       </p:grpSpPr>
       <p:sp>
         <p:nvSpPr>
-          <p:cNvPr id="537" name="Google Shape;537;p19"/>
+          <p:cNvPr id="550" name="Google Shape;550;p19"/>
           <p:cNvSpPr/>
           <p:nvPr/>
         </p:nvSpPr>
@@ -33761,7 +34478,7 @@
       </p:sp>
       <p:sp>
         <p:nvSpPr>
-          <p:cNvPr id="538" name="Google Shape;538;p19"/>
+          <p:cNvPr id="551" name="Google Shape;551;p19"/>
           <p:cNvSpPr/>
           <p:nvPr/>
         </p:nvSpPr>
@@ -33812,7 +34529,7 @@
       </p:sp>
       <p:sp>
         <p:nvSpPr>
-          <p:cNvPr id="539" name="Google Shape;539;p19"/>
+          <p:cNvPr id="552" name="Google Shape;552;p19"/>
           <p:cNvSpPr/>
           <p:nvPr/>
         </p:nvSpPr>
@@ -33863,7 +34580,7 @@
       </p:sp>
       <p:sp>
         <p:nvSpPr>
-          <p:cNvPr id="540" name="Google Shape;540;p19"/>
+          <p:cNvPr id="553" name="Google Shape;553;p19"/>
           <p:cNvSpPr/>
           <p:nvPr/>
         </p:nvSpPr>
@@ -33914,7 +34631,7 @@
       </p:sp>
       <p:sp>
         <p:nvSpPr>
-          <p:cNvPr id="541" name="Google Shape;541;p19"/>
+          <p:cNvPr id="554" name="Google Shape;554;p19"/>
           <p:cNvSpPr/>
           <p:nvPr/>
         </p:nvSpPr>
@@ -33965,7 +34682,7 @@
       </p:sp>
       <p:sp>
         <p:nvSpPr>
-          <p:cNvPr id="542" name="Google Shape;542;p19"/>
+          <p:cNvPr id="555" name="Google Shape;555;p19"/>
           <p:cNvSpPr/>
           <p:nvPr/>
         </p:nvSpPr>
@@ -34016,7 +34733,7 @@
       </p:sp>
       <p:sp>
         <p:nvSpPr>
-          <p:cNvPr id="543" name="Google Shape;543;p19"/>
+          <p:cNvPr id="556" name="Google Shape;556;p19"/>
           <p:cNvSpPr/>
           <p:nvPr/>
         </p:nvSpPr>
@@ -34067,7 +34784,7 @@
       </p:sp>
       <p:sp>
         <p:nvSpPr>
-          <p:cNvPr id="544" name="Google Shape;544;p19"/>
+          <p:cNvPr id="557" name="Google Shape;557;p19"/>
           <p:cNvSpPr/>
           <p:nvPr/>
         </p:nvSpPr>
@@ -34118,7 +34835,7 @@
       </p:sp>
       <p:sp>
         <p:nvSpPr>
-          <p:cNvPr id="545" name="Google Shape;545;p19"/>
+          <p:cNvPr id="558" name="Google Shape;558;p19"/>
           <p:cNvSpPr/>
           <p:nvPr/>
         </p:nvSpPr>
@@ -34169,7 +34886,7 @@
       </p:sp>
       <p:sp>
         <p:nvSpPr>
-          <p:cNvPr id="546" name="Google Shape;546;p19"/>
+          <p:cNvPr id="559" name="Google Shape;559;p19"/>
           <p:cNvSpPr/>
           <p:nvPr/>
         </p:nvSpPr>
@@ -34220,7 +34937,7 @@
       </p:sp>
       <p:sp>
         <p:nvSpPr>
-          <p:cNvPr id="547" name="Google Shape;547;p19"/>
+          <p:cNvPr id="560" name="Google Shape;560;p19"/>
           <p:cNvSpPr/>
           <p:nvPr/>
         </p:nvSpPr>
@@ -34271,7 +34988,7 @@
       </p:sp>
       <p:sp>
         <p:nvSpPr>
-          <p:cNvPr id="548" name="Google Shape;548;p19"/>
+          <p:cNvPr id="561" name="Google Shape;561;p19"/>
           <p:cNvSpPr/>
           <p:nvPr/>
         </p:nvSpPr>
@@ -34322,7 +35039,7 @@
       </p:sp>
       <p:sp>
         <p:nvSpPr>
-          <p:cNvPr id="549" name="Google Shape;549;p19"/>
+          <p:cNvPr id="562" name="Google Shape;562;p19"/>
           <p:cNvSpPr/>
           <p:nvPr/>
         </p:nvSpPr>
@@ -34373,7 +35090,7 @@
       </p:sp>
       <p:sp>
         <p:nvSpPr>
-          <p:cNvPr id="550" name="Google Shape;550;p19"/>
+          <p:cNvPr id="563" name="Google Shape;563;p19"/>
           <p:cNvSpPr/>
           <p:nvPr/>
         </p:nvSpPr>
@@ -34424,7 +35141,7 @@
       </p:sp>
       <p:sp>
         <p:nvSpPr>
-          <p:cNvPr id="551" name="Google Shape;551;p19"/>
+          <p:cNvPr id="564" name="Google Shape;564;p19"/>
           <p:cNvSpPr/>
           <p:nvPr/>
         </p:nvSpPr>
@@ -34475,7 +35192,7 @@
       </p:sp>
       <p:sp>
         <p:nvSpPr>
-          <p:cNvPr id="552" name="Google Shape;552;p19"/>
+          <p:cNvPr id="565" name="Google Shape;565;p19"/>
           <p:cNvSpPr/>
           <p:nvPr/>
         </p:nvSpPr>
@@ -34526,7 +35243,7 @@
       </p:sp>
       <p:sp>
         <p:nvSpPr>
-          <p:cNvPr id="553" name="Google Shape;553;p19"/>
+          <p:cNvPr id="566" name="Google Shape;566;p19"/>
           <p:cNvSpPr/>
           <p:nvPr/>
         </p:nvSpPr>
@@ -34577,7 +35294,7 @@
       </p:sp>
       <p:sp>
         <p:nvSpPr>
-          <p:cNvPr id="554" name="Google Shape;554;p19"/>
+          <p:cNvPr id="567" name="Google Shape;567;p19"/>
           <p:cNvSpPr/>
           <p:nvPr/>
         </p:nvSpPr>
@@ -34628,7 +35345,7 @@
       </p:sp>
       <p:sp>
         <p:nvSpPr>
-          <p:cNvPr id="555" name="Google Shape;555;p19"/>
+          <p:cNvPr id="568" name="Google Shape;568;p19"/>
           <p:cNvSpPr/>
           <p:nvPr/>
         </p:nvSpPr>
@@ -34679,7 +35396,7 @@
       </p:sp>
       <p:sp>
         <p:nvSpPr>
-          <p:cNvPr id="556" name="Google Shape;556;p19"/>
+          <p:cNvPr id="569" name="Google Shape;569;p19"/>
           <p:cNvSpPr/>
           <p:nvPr/>
         </p:nvSpPr>
@@ -34730,7 +35447,7 @@
       </p:sp>
       <p:sp>
         <p:nvSpPr>
-          <p:cNvPr id="557" name="Google Shape;557;p19"/>
+          <p:cNvPr id="570" name="Google Shape;570;p19"/>
           <p:cNvSpPr/>
           <p:nvPr/>
         </p:nvSpPr>
@@ -34781,7 +35498,7 @@
       </p:sp>
       <p:sp>
         <p:nvSpPr>
-          <p:cNvPr id="558" name="Google Shape;558;p19"/>
+          <p:cNvPr id="571" name="Google Shape;571;p19"/>
           <p:cNvSpPr/>
           <p:nvPr/>
         </p:nvSpPr>
@@ -34832,7 +35549,7 @@
       </p:sp>
       <p:sp>
         <p:nvSpPr>
-          <p:cNvPr id="559" name="Google Shape;559;p19"/>
+          <p:cNvPr id="572" name="Google Shape;572;p19"/>
           <p:cNvSpPr/>
           <p:nvPr/>
         </p:nvSpPr>
@@ -34883,7 +35600,7 @@
       </p:sp>
       <p:sp>
         <p:nvSpPr>
-          <p:cNvPr id="560" name="Google Shape;560;p19"/>
+          <p:cNvPr id="573" name="Google Shape;573;p19"/>
           <p:cNvSpPr/>
           <p:nvPr/>
         </p:nvSpPr>
@@ -34934,7 +35651,7 @@
       </p:sp>
       <p:sp>
         <p:nvSpPr>
-          <p:cNvPr id="561" name="Google Shape;561;p19"/>
+          <p:cNvPr id="574" name="Google Shape;574;p19"/>
           <p:cNvSpPr/>
           <p:nvPr/>
         </p:nvSpPr>
@@ -34985,7 +35702,7 @@
       </p:sp>
       <p:sp>
         <p:nvSpPr>
-          <p:cNvPr id="562" name="Google Shape;562;p19"/>
+          <p:cNvPr id="575" name="Google Shape;575;p19"/>
           <p:cNvSpPr/>
           <p:nvPr/>
         </p:nvSpPr>
@@ -35036,7 +35753,7 @@
       </p:sp>
       <p:sp>
         <p:nvSpPr>
-          <p:cNvPr id="563" name="Google Shape;563;p19"/>
+          <p:cNvPr id="576" name="Google Shape;576;p19"/>
           <p:cNvSpPr/>
           <p:nvPr/>
         </p:nvSpPr>
@@ -35087,7 +35804,7 @@
       </p:sp>
       <p:sp>
         <p:nvSpPr>
-          <p:cNvPr id="564" name="Google Shape;564;p19"/>
+          <p:cNvPr id="577" name="Google Shape;577;p19"/>
           <p:cNvSpPr/>
           <p:nvPr/>
         </p:nvSpPr>
@@ -35138,7 +35855,7 @@
       </p:sp>
       <p:sp>
         <p:nvSpPr>
-          <p:cNvPr id="565" name="Google Shape;565;p19"/>
+          <p:cNvPr id="578" name="Google Shape;578;p19"/>
           <p:cNvSpPr/>
           <p:nvPr/>
         </p:nvSpPr>
@@ -35189,7 +35906,7 @@
       </p:sp>
       <p:sp>
         <p:nvSpPr>
-          <p:cNvPr id="566" name="Google Shape;566;p19"/>
+          <p:cNvPr id="579" name="Google Shape;579;p19"/>
           <p:cNvSpPr/>
           <p:nvPr/>
         </p:nvSpPr>
@@ -35240,7 +35957,7 @@
       </p:sp>
       <p:sp>
         <p:nvSpPr>
-          <p:cNvPr id="567" name="Google Shape;567;p19"/>
+          <p:cNvPr id="580" name="Google Shape;580;p19"/>
           <p:cNvSpPr/>
           <p:nvPr/>
         </p:nvSpPr>
@@ -35291,7 +36008,7 @@
       </p:sp>
       <p:sp>
         <p:nvSpPr>
-          <p:cNvPr id="568" name="Google Shape;568;p19"/>
+          <p:cNvPr id="581" name="Google Shape;581;p19"/>
           <p:cNvSpPr/>
           <p:nvPr/>
         </p:nvSpPr>
@@ -35342,7 +36059,7 @@
       </p:sp>
       <p:sp>
         <p:nvSpPr>
-          <p:cNvPr id="569" name="Google Shape;569;p19"/>
+          <p:cNvPr id="582" name="Google Shape;582;p19"/>
           <p:cNvSpPr/>
           <p:nvPr/>
         </p:nvSpPr>
@@ -35393,7 +36110,7 @@
       </p:sp>
       <p:sp>
         <p:nvSpPr>
-          <p:cNvPr id="570" name="Google Shape;570;p19"/>
+          <p:cNvPr id="583" name="Google Shape;583;p19"/>
           <p:cNvSpPr/>
           <p:nvPr/>
         </p:nvSpPr>
@@ -35444,7 +36161,7 @@
       </p:sp>
       <p:sp>
         <p:nvSpPr>
-          <p:cNvPr id="571" name="Google Shape;571;p19"/>
+          <p:cNvPr id="584" name="Google Shape;584;p19"/>
           <p:cNvSpPr/>
           <p:nvPr/>
         </p:nvSpPr>
@@ -35495,7 +36212,7 @@
       </p:sp>
       <p:sp>
         <p:nvSpPr>
-          <p:cNvPr id="572" name="Google Shape;572;p19"/>
+          <p:cNvPr id="585" name="Google Shape;585;p19"/>
           <p:cNvSpPr/>
           <p:nvPr/>
         </p:nvSpPr>
@@ -35546,7 +36263,7 @@
       </p:sp>
       <p:sp>
         <p:nvSpPr>
-          <p:cNvPr id="573" name="Google Shape;573;p19"/>
+          <p:cNvPr id="586" name="Google Shape;586;p19"/>
           <p:cNvSpPr/>
           <p:nvPr/>
         </p:nvSpPr>
@@ -35597,7 +36314,7 @@
       </p:sp>
       <p:sp>
         <p:nvSpPr>
-          <p:cNvPr id="574" name="Google Shape;574;p19"/>
+          <p:cNvPr id="587" name="Google Shape;587;p19"/>
           <p:cNvSpPr/>
           <p:nvPr/>
         </p:nvSpPr>
@@ -35648,7 +36365,7 @@
       </p:sp>
       <p:sp>
         <p:nvSpPr>
-          <p:cNvPr id="575" name="Google Shape;575;p19"/>
+          <p:cNvPr id="588" name="Google Shape;588;p19"/>
           <p:cNvSpPr/>
           <p:nvPr/>
         </p:nvSpPr>
@@ -35699,7 +36416,7 @@
       </p:sp>
       <p:sp>
         <p:nvSpPr>
-          <p:cNvPr id="576" name="Google Shape;576;p19"/>
+          <p:cNvPr id="589" name="Google Shape;589;p19"/>
           <p:cNvSpPr/>
           <p:nvPr/>
         </p:nvSpPr>
@@ -35750,7 +36467,7 @@
       </p:sp>
       <p:sp>
         <p:nvSpPr>
-          <p:cNvPr id="577" name="Google Shape;577;p19"/>
+          <p:cNvPr id="590" name="Google Shape;590;p19"/>
           <p:cNvSpPr/>
           <p:nvPr/>
         </p:nvSpPr>
@@ -35801,7 +36518,7 @@
       </p:sp>
       <p:sp>
         <p:nvSpPr>
-          <p:cNvPr id="578" name="Google Shape;578;p19"/>
+          <p:cNvPr id="591" name="Google Shape;591;p19"/>
           <p:cNvSpPr/>
           <p:nvPr/>
         </p:nvSpPr>
@@ -35852,7 +36569,7 @@
       </p:sp>
       <p:sp>
         <p:nvSpPr>
-          <p:cNvPr id="579" name="Google Shape;579;p19"/>
+          <p:cNvPr id="592" name="Google Shape;592;p19"/>
           <p:cNvSpPr/>
           <p:nvPr/>
         </p:nvSpPr>
@@ -35903,7 +36620,7 @@
       </p:sp>
       <p:sp>
         <p:nvSpPr>
-          <p:cNvPr id="580" name="Google Shape;580;p19"/>
+          <p:cNvPr id="593" name="Google Shape;593;p19"/>
           <p:cNvSpPr/>
           <p:nvPr/>
         </p:nvSpPr>
@@ -35954,7 +36671,7 @@
       </p:sp>
       <p:sp>
         <p:nvSpPr>
-          <p:cNvPr id="581" name="Google Shape;581;p19"/>
+          <p:cNvPr id="594" name="Google Shape;594;p19"/>
           <p:cNvSpPr/>
           <p:nvPr/>
         </p:nvSpPr>
@@ -36005,7 +36722,7 @@
       </p:sp>
       <p:sp>
         <p:nvSpPr>
-          <p:cNvPr id="582" name="Google Shape;582;p19"/>
+          <p:cNvPr id="595" name="Google Shape;595;p19"/>
           <p:cNvSpPr txBox="1"/>
           <p:nvPr/>
         </p:nvSpPr>
@@ -36068,9 +36785,62 @@
           </a:p>
         </p:txBody>
       </p:sp>
+      <p:sp>
+        <p:nvSpPr>
+          <p:cNvPr id="596" name="Google Shape;596;p19"/>
+          <p:cNvSpPr txBox="1"/>
+          <p:nvPr/>
+        </p:nvSpPr>
+        <p:spPr>
+          <a:xfrm>
+            <a:off x="640080" y="841248"/>
+            <a:ext cx="10972800" cy="914400"/>
+          </a:xfrm>
+          <a:prstGeom prst="rect">
+            <a:avLst/>
+          </a:prstGeom>
+          <a:noFill/>
+          <a:ln>
+            <a:noFill/>
+          </a:ln>
+        </p:spPr>
+        <p:txBody>
+          <a:bodyPr anchorCtr="0" anchor="t" bIns="45700" lIns="91425" spcFirstLastPara="1" rIns="91425" wrap="square" tIns="45700">
+            <a:spAutoFit/>
+          </a:bodyPr>
+          <a:lstStyle/>
+          <a:p>
+            <a:pPr indent="0" lvl="0" marL="0" marR="0" rtl="0" algn="l">
+              <a:lnSpc>
+                <a:spcPct val="100000"/>
+              </a:lnSpc>
+              <a:spcBef>
+                <a:spcPts val="0"/>
+              </a:spcBef>
+              <a:spcAft>
+                <a:spcPts val="0"/>
+              </a:spcAft>
+              <a:buNone/>
+            </a:pPr>
+            <a:r>
+              <a:rPr b="1" i="0" lang="en-US" sz="3400" u="none" cap="none" strike="noStrike">
+                <a:solidFill>
+                  <a:srgbClr val="FFFFFF"/>
+                </a:solidFill>
+                <a:latin typeface="Quattrocento Sans"/>
+                <a:ea typeface="Quattrocento Sans"/>
+                <a:cs typeface="Quattrocento Sans"/>
+                <a:sym typeface="Quattrocento Sans"/>
+              </a:rPr>
+              <a:t>Scatter-gather over Kafka</a:t>
+            </a:r>
+            <a:endParaRPr/>
+          </a:p>
+        </p:txBody>
+      </p:sp>
       <p:pic>
         <p:nvPicPr>
-          <p:cNvPr descr="architecture.png" id="583" name="Google Shape;583;p19"/>
+          <p:cNvPr descr="architecture.png" id="597" name="Google Shape;597;p19"/>
           <p:cNvPicPr preferRelativeResize="0"/>
           <p:nvPr/>
         </p:nvPicPr>
@@ -36083,8 +36853,8 @@
         </p:blipFill>
         <p:spPr>
           <a:xfrm>
-            <a:off x="700464" y="1013580"/>
-            <a:ext cx="10607042" cy="5785659"/>
+            <a:off x="2459349" y="1783080"/>
+            <a:ext cx="7879080" cy="4297680"/>
           </a:xfrm>
           <a:prstGeom prst="rect">
             <a:avLst/>
@@ -36097,7 +36867,7 @@
       </p:pic>
       <p:sp>
         <p:nvSpPr>
-          <p:cNvPr id="584" name="Google Shape;584;p19"/>
+          <p:cNvPr id="598" name="Google Shape;598;p19"/>
           <p:cNvSpPr txBox="1"/>
           <p:nvPr/>
         </p:nvSpPr>
@@ -36142,7 +36912,7 @@
                 <a:cs typeface="Quattrocento Sans"/>
                 <a:sym typeface="Quattrocento Sans"/>
               </a:rPr>
-              <a:t>Two engines screen every payment in parallel — name/identity + network exposure — and the accumulator escalates to the worst verdict.</a:t>
+              <a:t>Two engines screen every payment in parallel — name/identity + network exposure; the accumulator escalates to the worst verdict, and a local LLM explains it.</a:t>
             </a:r>
             <a:endParaRPr/>
           </a:p>
@@ -36161,7 +36931,7 @@
   <p:cSld>
     <p:spTree>
       <p:nvGrpSpPr>
-        <p:cNvPr id="588" name="Shape 588"/>
+        <p:cNvPr id="602" name="Shape 602"/>
         <p:cNvGrpSpPr/>
         <p:nvPr/>
       </p:nvGrpSpPr>
@@ -36175,7 +36945,7 @@
       </p:grpSpPr>
       <p:sp>
         <p:nvSpPr>
-          <p:cNvPr id="589" name="Google Shape;589;p20"/>
+          <p:cNvPr id="603" name="Google Shape;603;p20"/>
           <p:cNvSpPr/>
           <p:nvPr/>
         </p:nvSpPr>
@@ -36226,7 +36996,7 @@
       </p:sp>
       <p:sp>
         <p:nvSpPr>
-          <p:cNvPr id="590" name="Google Shape;590;p20"/>
+          <p:cNvPr id="604" name="Google Shape;604;p20"/>
           <p:cNvSpPr/>
           <p:nvPr/>
         </p:nvSpPr>
@@ -36277,7 +37047,7 @@
       </p:sp>
       <p:sp>
         <p:nvSpPr>
-          <p:cNvPr id="591" name="Google Shape;591;p20"/>
+          <p:cNvPr id="605" name="Google Shape;605;p20"/>
           <p:cNvSpPr/>
           <p:nvPr/>
         </p:nvSpPr>
@@ -36328,7 +37098,7 @@
       </p:sp>
       <p:sp>
         <p:nvSpPr>
-          <p:cNvPr id="592" name="Google Shape;592;p20"/>
+          <p:cNvPr id="606" name="Google Shape;606;p20"/>
           <p:cNvSpPr/>
           <p:nvPr/>
         </p:nvSpPr>
@@ -36379,7 +37149,7 @@
       </p:sp>
       <p:sp>
         <p:nvSpPr>
-          <p:cNvPr id="593" name="Google Shape;593;p20"/>
+          <p:cNvPr id="607" name="Google Shape;607;p20"/>
           <p:cNvSpPr/>
           <p:nvPr/>
         </p:nvSpPr>
@@ -36430,7 +37200,7 @@
       </p:sp>
       <p:sp>
         <p:nvSpPr>
-          <p:cNvPr id="594" name="Google Shape;594;p20"/>
+          <p:cNvPr id="608" name="Google Shape;608;p20"/>
           <p:cNvSpPr/>
           <p:nvPr/>
         </p:nvSpPr>
@@ -36481,7 +37251,7 @@
       </p:sp>
       <p:sp>
         <p:nvSpPr>
-          <p:cNvPr id="595" name="Google Shape;595;p20"/>
+          <p:cNvPr id="609" name="Google Shape;609;p20"/>
           <p:cNvSpPr/>
           <p:nvPr/>
         </p:nvSpPr>
@@ -36532,7 +37302,7 @@
       </p:sp>
       <p:sp>
         <p:nvSpPr>
-          <p:cNvPr id="596" name="Google Shape;596;p20"/>
+          <p:cNvPr id="610" name="Google Shape;610;p20"/>
           <p:cNvSpPr/>
           <p:nvPr/>
         </p:nvSpPr>
@@ -36583,7 +37353,7 @@
       </p:sp>
       <p:sp>
         <p:nvSpPr>
-          <p:cNvPr id="597" name="Google Shape;597;p20"/>
+          <p:cNvPr id="611" name="Google Shape;611;p20"/>
           <p:cNvSpPr/>
           <p:nvPr/>
         </p:nvSpPr>
@@ -36634,7 +37404,7 @@
       </p:sp>
       <p:sp>
         <p:nvSpPr>
-          <p:cNvPr id="598" name="Google Shape;598;p20"/>
+          <p:cNvPr id="612" name="Google Shape;612;p20"/>
           <p:cNvSpPr/>
           <p:nvPr/>
         </p:nvSpPr>
@@ -36685,7 +37455,7 @@
       </p:sp>
       <p:sp>
         <p:nvSpPr>
-          <p:cNvPr id="599" name="Google Shape;599;p20"/>
+          <p:cNvPr id="613" name="Google Shape;613;p20"/>
           <p:cNvSpPr/>
           <p:nvPr/>
         </p:nvSpPr>
@@ -36736,7 +37506,7 @@
       </p:sp>
       <p:sp>
         <p:nvSpPr>
-          <p:cNvPr id="600" name="Google Shape;600;p20"/>
+          <p:cNvPr id="614" name="Google Shape;614;p20"/>
           <p:cNvSpPr/>
           <p:nvPr/>
         </p:nvSpPr>
@@ -36787,7 +37557,7 @@
       </p:sp>
       <p:sp>
         <p:nvSpPr>
-          <p:cNvPr id="601" name="Google Shape;601;p20"/>
+          <p:cNvPr id="615" name="Google Shape;615;p20"/>
           <p:cNvSpPr/>
           <p:nvPr/>
         </p:nvSpPr>
@@ -36838,7 +37608,7 @@
       </p:sp>
       <p:sp>
         <p:nvSpPr>
-          <p:cNvPr id="602" name="Google Shape;602;p20"/>
+          <p:cNvPr id="616" name="Google Shape;616;p20"/>
           <p:cNvSpPr/>
           <p:nvPr/>
         </p:nvSpPr>
@@ -36889,7 +37659,7 @@
       </p:sp>
       <p:sp>
         <p:nvSpPr>
-          <p:cNvPr id="603" name="Google Shape;603;p20"/>
+          <p:cNvPr id="617" name="Google Shape;617;p20"/>
           <p:cNvSpPr/>
           <p:nvPr/>
         </p:nvSpPr>
@@ -36940,7 +37710,7 @@
       </p:sp>
       <p:sp>
         <p:nvSpPr>
-          <p:cNvPr id="604" name="Google Shape;604;p20"/>
+          <p:cNvPr id="618" name="Google Shape;618;p20"/>
           <p:cNvSpPr/>
           <p:nvPr/>
         </p:nvSpPr>
@@ -36991,7 +37761,7 @@
       </p:sp>
       <p:sp>
         <p:nvSpPr>
-          <p:cNvPr id="605" name="Google Shape;605;p20"/>
+          <p:cNvPr id="619" name="Google Shape;619;p20"/>
           <p:cNvSpPr/>
           <p:nvPr/>
         </p:nvSpPr>
@@ -37042,7 +37812,7 @@
       </p:sp>
       <p:sp>
         <p:nvSpPr>
-          <p:cNvPr id="606" name="Google Shape;606;p20"/>
+          <p:cNvPr id="620" name="Google Shape;620;p20"/>
           <p:cNvSpPr/>
           <p:nvPr/>
         </p:nvSpPr>
@@ -37093,7 +37863,7 @@
       </p:sp>
       <p:sp>
         <p:nvSpPr>
-          <p:cNvPr id="607" name="Google Shape;607;p20"/>
+          <p:cNvPr id="621" name="Google Shape;621;p20"/>
           <p:cNvSpPr/>
           <p:nvPr/>
         </p:nvSpPr>
@@ -37144,7 +37914,7 @@
       </p:sp>
       <p:sp>
         <p:nvSpPr>
-          <p:cNvPr id="608" name="Google Shape;608;p20"/>
+          <p:cNvPr id="622" name="Google Shape;622;p20"/>
           <p:cNvSpPr/>
           <p:nvPr/>
         </p:nvSpPr>
@@ -37195,7 +37965,7 @@
       </p:sp>
       <p:sp>
         <p:nvSpPr>
-          <p:cNvPr id="609" name="Google Shape;609;p20"/>
+          <p:cNvPr id="623" name="Google Shape;623;p20"/>
           <p:cNvSpPr/>
           <p:nvPr/>
         </p:nvSpPr>
@@ -37246,7 +38016,7 @@
       </p:sp>
       <p:sp>
         <p:nvSpPr>
-          <p:cNvPr id="610" name="Google Shape;610;p20"/>
+          <p:cNvPr id="624" name="Google Shape;624;p20"/>
           <p:cNvSpPr/>
           <p:nvPr/>
         </p:nvSpPr>
@@ -37297,7 +38067,7 @@
       </p:sp>
       <p:sp>
         <p:nvSpPr>
-          <p:cNvPr id="611" name="Google Shape;611;p20"/>
+          <p:cNvPr id="625" name="Google Shape;625;p20"/>
           <p:cNvSpPr/>
           <p:nvPr/>
         </p:nvSpPr>
@@ -37348,7 +38118,7 @@
       </p:sp>
       <p:sp>
         <p:nvSpPr>
-          <p:cNvPr id="612" name="Google Shape;612;p20"/>
+          <p:cNvPr id="626" name="Google Shape;626;p20"/>
           <p:cNvSpPr/>
           <p:nvPr/>
         </p:nvSpPr>
@@ -37399,7 +38169,7 @@
       </p:sp>
       <p:sp>
         <p:nvSpPr>
-          <p:cNvPr id="613" name="Google Shape;613;p20"/>
+          <p:cNvPr id="627" name="Google Shape;627;p20"/>
           <p:cNvSpPr/>
           <p:nvPr/>
         </p:nvSpPr>
@@ -37450,7 +38220,7 @@
       </p:sp>
       <p:sp>
         <p:nvSpPr>
-          <p:cNvPr id="614" name="Google Shape;614;p20"/>
+          <p:cNvPr id="628" name="Google Shape;628;p20"/>
           <p:cNvSpPr/>
           <p:nvPr/>
         </p:nvSpPr>
@@ -37501,7 +38271,7 @@
       </p:sp>
       <p:sp>
         <p:nvSpPr>
-          <p:cNvPr id="615" name="Google Shape;615;p20"/>
+          <p:cNvPr id="629" name="Google Shape;629;p20"/>
           <p:cNvSpPr/>
           <p:nvPr/>
         </p:nvSpPr>
@@ -37552,7 +38322,7 @@
       </p:sp>
       <p:sp>
         <p:nvSpPr>
-          <p:cNvPr id="616" name="Google Shape;616;p20"/>
+          <p:cNvPr id="630" name="Google Shape;630;p20"/>
           <p:cNvSpPr/>
           <p:nvPr/>
         </p:nvSpPr>
@@ -37603,7 +38373,7 @@
       </p:sp>
       <p:sp>
         <p:nvSpPr>
-          <p:cNvPr id="617" name="Google Shape;617;p20"/>
+          <p:cNvPr id="631" name="Google Shape;631;p20"/>
           <p:cNvSpPr/>
           <p:nvPr/>
         </p:nvSpPr>
@@ -37654,7 +38424,7 @@
       </p:sp>
       <p:sp>
         <p:nvSpPr>
-          <p:cNvPr id="618" name="Google Shape;618;p20"/>
+          <p:cNvPr id="632" name="Google Shape;632;p20"/>
           <p:cNvSpPr/>
           <p:nvPr/>
         </p:nvSpPr>
@@ -37705,7 +38475,7 @@
       </p:sp>
       <p:sp>
         <p:nvSpPr>
-          <p:cNvPr id="619" name="Google Shape;619;p20"/>
+          <p:cNvPr id="633" name="Google Shape;633;p20"/>
           <p:cNvSpPr/>
           <p:nvPr/>
         </p:nvSpPr>
@@ -37756,7 +38526,7 @@
       </p:sp>
       <p:sp>
         <p:nvSpPr>
-          <p:cNvPr id="620" name="Google Shape;620;p20"/>
+          <p:cNvPr id="634" name="Google Shape;634;p20"/>
           <p:cNvSpPr/>
           <p:nvPr/>
         </p:nvSpPr>
@@ -37807,7 +38577,7 @@
       </p:sp>
       <p:sp>
         <p:nvSpPr>
-          <p:cNvPr id="621" name="Google Shape;621;p20"/>
+          <p:cNvPr id="635" name="Google Shape;635;p20"/>
           <p:cNvSpPr/>
           <p:nvPr/>
         </p:nvSpPr>
@@ -37858,7 +38628,7 @@
       </p:sp>
       <p:sp>
         <p:nvSpPr>
-          <p:cNvPr id="622" name="Google Shape;622;p20"/>
+          <p:cNvPr id="636" name="Google Shape;636;p20"/>
           <p:cNvSpPr/>
           <p:nvPr/>
         </p:nvSpPr>
@@ -37909,7 +38679,7 @@
       </p:sp>
       <p:sp>
         <p:nvSpPr>
-          <p:cNvPr id="623" name="Google Shape;623;p20"/>
+          <p:cNvPr id="637" name="Google Shape;637;p20"/>
           <p:cNvSpPr/>
           <p:nvPr/>
         </p:nvSpPr>
@@ -37960,7 +38730,7 @@
       </p:sp>
       <p:sp>
         <p:nvSpPr>
-          <p:cNvPr id="624" name="Google Shape;624;p20"/>
+          <p:cNvPr id="638" name="Google Shape;638;p20"/>
           <p:cNvSpPr/>
           <p:nvPr/>
         </p:nvSpPr>
@@ -38011,7 +38781,7 @@
       </p:sp>
       <p:sp>
         <p:nvSpPr>
-          <p:cNvPr id="625" name="Google Shape;625;p20"/>
+          <p:cNvPr id="639" name="Google Shape;639;p20"/>
           <p:cNvSpPr/>
           <p:nvPr/>
         </p:nvSpPr>
@@ -38062,7 +38832,7 @@
       </p:sp>
       <p:sp>
         <p:nvSpPr>
-          <p:cNvPr id="626" name="Google Shape;626;p20"/>
+          <p:cNvPr id="640" name="Google Shape;640;p20"/>
           <p:cNvSpPr/>
           <p:nvPr/>
         </p:nvSpPr>
@@ -38113,7 +38883,7 @@
       </p:sp>
       <p:sp>
         <p:nvSpPr>
-          <p:cNvPr id="627" name="Google Shape;627;p20"/>
+          <p:cNvPr id="641" name="Google Shape;641;p20"/>
           <p:cNvSpPr/>
           <p:nvPr/>
         </p:nvSpPr>
@@ -38164,7 +38934,7 @@
       </p:sp>
       <p:sp>
         <p:nvSpPr>
-          <p:cNvPr id="628" name="Google Shape;628;p20"/>
+          <p:cNvPr id="642" name="Google Shape;642;p20"/>
           <p:cNvSpPr/>
           <p:nvPr/>
         </p:nvSpPr>
@@ -38215,7 +38985,7 @@
       </p:sp>
       <p:sp>
         <p:nvSpPr>
-          <p:cNvPr id="629" name="Google Shape;629;p20"/>
+          <p:cNvPr id="643" name="Google Shape;643;p20"/>
           <p:cNvSpPr/>
           <p:nvPr/>
         </p:nvSpPr>
@@ -38266,7 +39036,7 @@
       </p:sp>
       <p:sp>
         <p:nvSpPr>
-          <p:cNvPr id="630" name="Google Shape;630;p20"/>
+          <p:cNvPr id="644" name="Google Shape;644;p20"/>
           <p:cNvSpPr/>
           <p:nvPr/>
         </p:nvSpPr>
@@ -38317,7 +39087,7 @@
       </p:sp>
       <p:sp>
         <p:nvSpPr>
-          <p:cNvPr id="631" name="Google Shape;631;p20"/>
+          <p:cNvPr id="645" name="Google Shape;645;p20"/>
           <p:cNvSpPr/>
           <p:nvPr/>
         </p:nvSpPr>
@@ -38368,7 +39138,7 @@
       </p:sp>
       <p:sp>
         <p:nvSpPr>
-          <p:cNvPr id="632" name="Google Shape;632;p20"/>
+          <p:cNvPr id="646" name="Google Shape;646;p20"/>
           <p:cNvSpPr/>
           <p:nvPr/>
         </p:nvSpPr>
@@ -38419,7 +39189,7 @@
       </p:sp>
       <p:sp>
         <p:nvSpPr>
-          <p:cNvPr id="633" name="Google Shape;633;p20"/>
+          <p:cNvPr id="647" name="Google Shape;647;p20"/>
           <p:cNvSpPr/>
           <p:nvPr/>
         </p:nvSpPr>
@@ -38470,7 +39240,7 @@
       </p:sp>
       <p:sp>
         <p:nvSpPr>
-          <p:cNvPr id="634" name="Google Shape;634;p20"/>
+          <p:cNvPr id="648" name="Google Shape;648;p20"/>
           <p:cNvSpPr txBox="1"/>
           <p:nvPr/>
         </p:nvSpPr>
@@ -38535,7 +39305,7 @@
       </p:sp>
       <p:sp>
         <p:nvSpPr>
-          <p:cNvPr id="635" name="Google Shape;635;p20"/>
+          <p:cNvPr id="649" name="Google Shape;649;p20"/>
           <p:cNvSpPr txBox="1"/>
           <p:nvPr/>
         </p:nvSpPr>
@@ -38588,7 +39358,7 @@
       </p:sp>
       <p:pic>
         <p:nvPicPr>
-          <p:cNvPr descr="front.png" id="636" name="Google Shape;636;p20"/>
+          <p:cNvPr descr="front.png" id="650" name="Google Shape;650;p20"/>
           <p:cNvPicPr preferRelativeResize="0"/>
           <p:nvPr/>
         </p:nvPicPr>
@@ -38601,7 +39371,7 @@
         </p:blipFill>
         <p:spPr>
           <a:xfrm>
-            <a:off x="1214902" y="1441375"/>
+            <a:off x="1365277" y="1471013"/>
             <a:ext cx="9692642" cy="4603499"/>
           </a:xfrm>
           <a:prstGeom prst="rect">
@@ -38615,7 +39385,7 @@
       </p:pic>
       <p:sp>
         <p:nvSpPr>
-          <p:cNvPr id="637" name="Google Shape;637;p20"/>
+          <p:cNvPr id="651" name="Google Shape;651;p20"/>
           <p:cNvSpPr txBox="1"/>
           <p:nvPr/>
         </p:nvSpPr>
@@ -38680,7 +39450,7 @@
       </p:sp>
       <p:pic>
         <p:nvPicPr>
-          <p:cNvPr descr="garaza_logo.png" id="638" name="Google Shape;638;p20"/>
+          <p:cNvPr descr="garaza_logo.png" id="652" name="Google Shape;652;p20"/>
           <p:cNvPicPr preferRelativeResize="0"/>
           <p:nvPr/>
         </p:nvPicPr>
@@ -38707,7 +39477,7 @@
       </p:pic>
       <p:sp>
         <p:nvSpPr>
-          <p:cNvPr id="639" name="Google Shape;639;p20"/>
+          <p:cNvPr id="653" name="Google Shape;653;p20"/>
           <p:cNvSpPr txBox="1"/>
           <p:nvPr/>
         </p:nvSpPr>

</xml_diff>